<commit_message>
Replace template 22 with new version (Informative Presentation v2 - book/education theme)
</commit_message>
<xml_diff>
--- a/templates/shablonlar/22.pptx
+++ b/templates/shablonlar/22.pptx
@@ -7,10 +7,10 @@
   <p:sldIdLst>
     <p:sldId id="256" r:id="rId2"/>
     <p:sldId id="257" r:id="rId3"/>
-    <p:sldId id="259" r:id="rId4"/>
-    <p:sldId id="261" r:id="rId5"/>
-    <p:sldId id="262" r:id="rId6"/>
-    <p:sldId id="263" r:id="rId7"/>
+    <p:sldId id="258" r:id="rId4"/>
+    <p:sldId id="259" r:id="rId5"/>
+    <p:sldId id="261" r:id="rId6"/>
+    <p:sldId id="262" r:id="rId7"/>
     <p:sldId id="264" r:id="rId8"/>
     <p:sldId id="266" r:id="rId9"/>
   </p:sldIdLst>
@@ -320,7 +320,7 @@
             <a:fld id="{1D8BD707-D9CF-40AE-B4C6-C98DA3205C09}" type="datetimeFigureOut">
               <a:rPr lang="en-US" smtClean="0"/>
               <a:pPr/>
-              <a:t>7/25/2026</a:t>
+              <a:t>7/26/2026</a:t>
             </a:fld>
             <a:endParaRPr lang="en-US"/>
           </a:p>
@@ -485,7 +485,7 @@
             <a:fld id="{1D8BD707-D9CF-40AE-B4C6-C98DA3205C09}" type="datetimeFigureOut">
               <a:rPr lang="en-US" smtClean="0"/>
               <a:pPr/>
-              <a:t>7/25/2026</a:t>
+              <a:t>7/26/2026</a:t>
             </a:fld>
             <a:endParaRPr lang="en-US"/>
           </a:p>
@@ -660,7 +660,7 @@
             <a:fld id="{1D8BD707-D9CF-40AE-B4C6-C98DA3205C09}" type="datetimeFigureOut">
               <a:rPr lang="en-US" smtClean="0"/>
               <a:pPr/>
-              <a:t>7/25/2026</a:t>
+              <a:t>7/26/2026</a:t>
             </a:fld>
             <a:endParaRPr lang="en-US"/>
           </a:p>
@@ -825,7 +825,7 @@
             <a:fld id="{1D8BD707-D9CF-40AE-B4C6-C98DA3205C09}" type="datetimeFigureOut">
               <a:rPr lang="en-US" smtClean="0"/>
               <a:pPr/>
-              <a:t>7/25/2026</a:t>
+              <a:t>7/26/2026</a:t>
             </a:fld>
             <a:endParaRPr lang="en-US"/>
           </a:p>
@@ -1067,7 +1067,7 @@
             <a:fld id="{1D8BD707-D9CF-40AE-B4C6-C98DA3205C09}" type="datetimeFigureOut">
               <a:rPr lang="en-US" smtClean="0"/>
               <a:pPr/>
-              <a:t>7/25/2026</a:t>
+              <a:t>7/26/2026</a:t>
             </a:fld>
             <a:endParaRPr lang="en-US"/>
           </a:p>
@@ -1349,7 +1349,7 @@
             <a:fld id="{1D8BD707-D9CF-40AE-B4C6-C98DA3205C09}" type="datetimeFigureOut">
               <a:rPr lang="en-US" smtClean="0"/>
               <a:pPr/>
-              <a:t>7/25/2026</a:t>
+              <a:t>7/26/2026</a:t>
             </a:fld>
             <a:endParaRPr lang="en-US"/>
           </a:p>
@@ -1765,7 +1765,7 @@
             <a:fld id="{1D8BD707-D9CF-40AE-B4C6-C98DA3205C09}" type="datetimeFigureOut">
               <a:rPr lang="en-US" smtClean="0"/>
               <a:pPr/>
-              <a:t>7/25/2026</a:t>
+              <a:t>7/26/2026</a:t>
             </a:fld>
             <a:endParaRPr lang="en-US"/>
           </a:p>
@@ -1879,7 +1879,7 @@
             <a:fld id="{1D8BD707-D9CF-40AE-B4C6-C98DA3205C09}" type="datetimeFigureOut">
               <a:rPr lang="en-US" smtClean="0"/>
               <a:pPr/>
-              <a:t>7/25/2026</a:t>
+              <a:t>7/26/2026</a:t>
             </a:fld>
             <a:endParaRPr lang="en-US"/>
           </a:p>
@@ -1971,7 +1971,7 @@
             <a:fld id="{1D8BD707-D9CF-40AE-B4C6-C98DA3205C09}" type="datetimeFigureOut">
               <a:rPr lang="en-US" smtClean="0"/>
               <a:pPr/>
-              <a:t>7/25/2026</a:t>
+              <a:t>7/26/2026</a:t>
             </a:fld>
             <a:endParaRPr lang="en-US"/>
           </a:p>
@@ -2243,7 +2243,7 @@
             <a:fld id="{1D8BD707-D9CF-40AE-B4C6-C98DA3205C09}" type="datetimeFigureOut">
               <a:rPr lang="en-US" smtClean="0"/>
               <a:pPr/>
-              <a:t>7/25/2026</a:t>
+              <a:t>7/26/2026</a:t>
             </a:fld>
             <a:endParaRPr lang="en-US"/>
           </a:p>
@@ -2492,7 +2492,7 @@
             <a:fld id="{1D8BD707-D9CF-40AE-B4C6-C98DA3205C09}" type="datetimeFigureOut">
               <a:rPr lang="en-US" smtClean="0"/>
               <a:pPr/>
-              <a:t>7/25/2026</a:t>
+              <a:t>7/26/2026</a:t>
             </a:fld>
             <a:endParaRPr lang="en-US"/>
           </a:p>
@@ -2700,7 +2700,7 @@
             <a:fld id="{1D8BD707-D9CF-40AE-B4C6-C98DA3205C09}" type="datetimeFigureOut">
               <a:rPr lang="en-US" smtClean="0"/>
               <a:pPr/>
-              <a:t>7/25/2026</a:t>
+              <a:t>7/26/2026</a:t>
             </a:fld>
             <a:endParaRPr lang="en-US"/>
           </a:p>
@@ -4170,14 +4170,14 @@
       </p:grpSpPr>
       <p:sp>
         <p:nvSpPr>
-          <p:cNvPr id="12" name="TextBox 12"/>
+          <p:cNvPr id="9" name="TextBox 9"/>
           <p:cNvSpPr txBox="1"/>
           <p:nvPr/>
         </p:nvSpPr>
         <p:spPr>
           <a:xfrm>
-            <a:off x="5640947" y="4562143"/>
-            <a:ext cx="4541635" cy="4611624"/>
+            <a:off x="2112436" y="3274990"/>
+            <a:ext cx="9537552" cy="2328672"/>
           </a:xfrm>
           <a:prstGeom prst="rect">
             <a:avLst/>
@@ -4191,13 +4191,13 @@
           <a:p>
             <a:pPr algn="l">
               <a:lnSpc>
-                <a:spcPts val="2808"/>
+                <a:spcPts val="3023"/>
               </a:lnSpc>
             </a:pPr>
             <a:r>
-              <a:rPr lang="en-US" sz="2600" dirty="0">
-                <a:solidFill>
-                  <a:srgbClr val="C15943"/>
+              <a:rPr lang="en-US" sz="2799" dirty="0">
+                <a:solidFill>
+                  <a:srgbClr val="571A0E"/>
                 </a:solidFill>
                 <a:latin typeface="Poppins"/>
                 <a:ea typeface="Poppins"/>
@@ -4207,9 +4207,9 @@
               <a:t>Lorem ipsum dolor sit </a:t>
             </a:r>
             <a:r>
-              <a:rPr lang="en-US" sz="2600" dirty="0" err="1">
-                <a:solidFill>
-                  <a:srgbClr val="C15943"/>
+              <a:rPr lang="en-US" sz="2799" dirty="0" err="1">
+                <a:solidFill>
+                  <a:srgbClr val="571A0E"/>
                 </a:solidFill>
                 <a:latin typeface="Poppins"/>
                 <a:ea typeface="Poppins"/>
@@ -4219,9 +4219,9 @@
               <a:t>amet</a:t>
             </a:r>
             <a:r>
-              <a:rPr lang="en-US" sz="2600" dirty="0">
-                <a:solidFill>
-                  <a:srgbClr val="C15943"/>
+              <a:rPr lang="en-US" sz="2799" dirty="0">
+                <a:solidFill>
+                  <a:srgbClr val="571A0E"/>
                 </a:solidFill>
                 <a:latin typeface="Poppins"/>
                 <a:ea typeface="Poppins"/>
@@ -4231,9 +4231,9 @@
               <a:t>, </a:t>
             </a:r>
             <a:r>
-              <a:rPr lang="en-US" sz="2600" dirty="0" err="1">
-                <a:solidFill>
-                  <a:srgbClr val="C15943"/>
+              <a:rPr lang="en-US" sz="2799" dirty="0" err="1">
+                <a:solidFill>
+                  <a:srgbClr val="571A0E"/>
                 </a:solidFill>
                 <a:latin typeface="Poppins"/>
                 <a:ea typeface="Poppins"/>
@@ -4243,9 +4243,9 @@
               <a:t>consectetur</a:t>
             </a:r>
             <a:r>
-              <a:rPr lang="en-US" sz="2600" dirty="0">
-                <a:solidFill>
-                  <a:srgbClr val="C15943"/>
+              <a:rPr lang="en-US" sz="2799" dirty="0">
+                <a:solidFill>
+                  <a:srgbClr val="571A0E"/>
                 </a:solidFill>
                 <a:latin typeface="Poppins"/>
                 <a:ea typeface="Poppins"/>
@@ -4255,9 +4255,9 @@
               <a:t> </a:t>
             </a:r>
             <a:r>
-              <a:rPr lang="en-US" sz="2600" dirty="0" err="1">
-                <a:solidFill>
-                  <a:srgbClr val="C15943"/>
+              <a:rPr lang="en-US" sz="2799" dirty="0" err="1">
+                <a:solidFill>
+                  <a:srgbClr val="571A0E"/>
                 </a:solidFill>
                 <a:latin typeface="Poppins"/>
                 <a:ea typeface="Poppins"/>
@@ -4267,9 +4267,9 @@
               <a:t>adipiscing</a:t>
             </a:r>
             <a:r>
-              <a:rPr lang="en-US" sz="2600" dirty="0">
-                <a:solidFill>
-                  <a:srgbClr val="C15943"/>
+              <a:rPr lang="en-US" sz="2799" dirty="0">
+                <a:solidFill>
+                  <a:srgbClr val="571A0E"/>
                 </a:solidFill>
                 <a:latin typeface="Poppins"/>
                 <a:ea typeface="Poppins"/>
@@ -4279,9 +4279,9 @@
               <a:t> </a:t>
             </a:r>
             <a:r>
-              <a:rPr lang="en-US" sz="2600" dirty="0" err="1">
-                <a:solidFill>
-                  <a:srgbClr val="C15943"/>
+              <a:rPr lang="en-US" sz="2799" dirty="0" err="1">
+                <a:solidFill>
+                  <a:srgbClr val="571A0E"/>
                 </a:solidFill>
                 <a:latin typeface="Poppins"/>
                 <a:ea typeface="Poppins"/>
@@ -4291,9 +4291,9 @@
               <a:t>elit</a:t>
             </a:r>
             <a:r>
-              <a:rPr lang="en-US" sz="2600" dirty="0">
-                <a:solidFill>
-                  <a:srgbClr val="C15943"/>
+              <a:rPr lang="en-US" sz="2799" dirty="0">
+                <a:solidFill>
+                  <a:srgbClr val="571A0E"/>
                 </a:solidFill>
                 <a:latin typeface="Poppins"/>
                 <a:ea typeface="Poppins"/>
@@ -4303,9 +4303,9 @@
               <a:t>. </a:t>
             </a:r>
             <a:r>
-              <a:rPr lang="en-US" sz="2600" dirty="0" err="1">
-                <a:solidFill>
-                  <a:srgbClr val="C15943"/>
+              <a:rPr lang="en-US" sz="2799" dirty="0" err="1">
+                <a:solidFill>
+                  <a:srgbClr val="571A0E"/>
                 </a:solidFill>
                 <a:latin typeface="Poppins"/>
                 <a:ea typeface="Poppins"/>
@@ -4315,9 +4315,9 @@
               <a:t>Quisque</a:t>
             </a:r>
             <a:r>
-              <a:rPr lang="en-US" sz="2600" dirty="0">
-                <a:solidFill>
-                  <a:srgbClr val="C15943"/>
+              <a:rPr lang="en-US" sz="2799" dirty="0">
+                <a:solidFill>
+                  <a:srgbClr val="571A0E"/>
                 </a:solidFill>
                 <a:latin typeface="Poppins"/>
                 <a:ea typeface="Poppins"/>
@@ -4327,9 +4327,9 @@
               <a:t> non </a:t>
             </a:r>
             <a:r>
-              <a:rPr lang="en-US" sz="2600" dirty="0" err="1">
-                <a:solidFill>
-                  <a:srgbClr val="C15943"/>
+              <a:rPr lang="en-US" sz="2799" dirty="0" err="1">
+                <a:solidFill>
+                  <a:srgbClr val="571A0E"/>
                 </a:solidFill>
                 <a:latin typeface="Poppins"/>
                 <a:ea typeface="Poppins"/>
@@ -4339,9 +4339,9 @@
               <a:t>elit</a:t>
             </a:r>
             <a:r>
-              <a:rPr lang="en-US" sz="2600" dirty="0">
-                <a:solidFill>
-                  <a:srgbClr val="C15943"/>
+              <a:rPr lang="en-US" sz="2799" dirty="0">
+                <a:solidFill>
+                  <a:srgbClr val="571A0E"/>
                 </a:solidFill>
                 <a:latin typeface="Poppins"/>
                 <a:ea typeface="Poppins"/>
@@ -4351,9 +4351,9 @@
               <a:t> </a:t>
             </a:r>
             <a:r>
-              <a:rPr lang="en-US" sz="2600" dirty="0" err="1">
-                <a:solidFill>
-                  <a:srgbClr val="C15943"/>
+              <a:rPr lang="en-US" sz="2799" dirty="0" err="1">
+                <a:solidFill>
+                  <a:srgbClr val="571A0E"/>
                 </a:solidFill>
                 <a:latin typeface="Poppins"/>
                 <a:ea typeface="Poppins"/>
@@ -4363,9 +4363,9 @@
               <a:t>mauris</a:t>
             </a:r>
             <a:r>
-              <a:rPr lang="en-US" sz="2600" dirty="0">
-                <a:solidFill>
-                  <a:srgbClr val="C15943"/>
+              <a:rPr lang="en-US" sz="2799" dirty="0">
+                <a:solidFill>
+                  <a:srgbClr val="571A0E"/>
                 </a:solidFill>
                 <a:latin typeface="Poppins"/>
                 <a:ea typeface="Poppins"/>
@@ -4375,9 +4375,9 @@
               <a:t>. Cras </a:t>
             </a:r>
             <a:r>
-              <a:rPr lang="en-US" sz="2600" dirty="0" err="1">
-                <a:solidFill>
-                  <a:srgbClr val="C15943"/>
+              <a:rPr lang="en-US" sz="2799" dirty="0" err="1">
+                <a:solidFill>
+                  <a:srgbClr val="571A0E"/>
                 </a:solidFill>
                 <a:latin typeface="Poppins"/>
                 <a:ea typeface="Poppins"/>
@@ -4387,9 +4387,9 @@
               <a:t>euismod</a:t>
             </a:r>
             <a:r>
-              <a:rPr lang="en-US" sz="2600" dirty="0">
-                <a:solidFill>
-                  <a:srgbClr val="C15943"/>
+              <a:rPr lang="en-US" sz="2799" dirty="0">
+                <a:solidFill>
+                  <a:srgbClr val="571A0E"/>
                 </a:solidFill>
                 <a:latin typeface="Poppins"/>
                 <a:ea typeface="Poppins"/>
@@ -4399,9 +4399,9 @@
               <a:t>, </a:t>
             </a:r>
             <a:r>
-              <a:rPr lang="en-US" sz="2600" dirty="0" err="1">
-                <a:solidFill>
-                  <a:srgbClr val="C15943"/>
+              <a:rPr lang="en-US" sz="2799" dirty="0" err="1">
+                <a:solidFill>
+                  <a:srgbClr val="571A0E"/>
                 </a:solidFill>
                 <a:latin typeface="Poppins"/>
                 <a:ea typeface="Poppins"/>
@@ -4411,9 +4411,9 @@
               <a:t>metus</a:t>
             </a:r>
             <a:r>
-              <a:rPr lang="en-US" sz="2600" dirty="0">
-                <a:solidFill>
-                  <a:srgbClr val="C15943"/>
+              <a:rPr lang="en-US" sz="2799" dirty="0">
+                <a:solidFill>
+                  <a:srgbClr val="571A0E"/>
                 </a:solidFill>
                 <a:latin typeface="Poppins"/>
                 <a:ea typeface="Poppins"/>
@@ -4423,9 +4423,9 @@
               <a:t> ac </a:t>
             </a:r>
             <a:r>
-              <a:rPr lang="en-US" sz="2600" dirty="0" err="1">
-                <a:solidFill>
-                  <a:srgbClr val="C15943"/>
+              <a:rPr lang="en-US" sz="2799" dirty="0" err="1">
+                <a:solidFill>
+                  <a:srgbClr val="571A0E"/>
                 </a:solidFill>
                 <a:latin typeface="Poppins"/>
                 <a:ea typeface="Poppins"/>
@@ -4435,9 +4435,9 @@
               <a:t>finibus</a:t>
             </a:r>
             <a:r>
-              <a:rPr lang="en-US" sz="2600" dirty="0">
-                <a:solidFill>
-                  <a:srgbClr val="C15943"/>
+              <a:rPr lang="en-US" sz="2799" dirty="0">
+                <a:solidFill>
+                  <a:srgbClr val="571A0E"/>
                 </a:solidFill>
                 <a:latin typeface="Poppins"/>
                 <a:ea typeface="Poppins"/>
@@ -4447,9 +4447,9 @@
               <a:t> </a:t>
             </a:r>
             <a:r>
-              <a:rPr lang="en-US" sz="2600" dirty="0" err="1">
-                <a:solidFill>
-                  <a:srgbClr val="C15943"/>
+              <a:rPr lang="en-US" sz="2799" dirty="0" err="1">
+                <a:solidFill>
+                  <a:srgbClr val="571A0E"/>
                 </a:solidFill>
                 <a:latin typeface="Poppins"/>
                 <a:ea typeface="Poppins"/>
@@ -4459,9 +4459,9 @@
               <a:t>finibus</a:t>
             </a:r>
             <a:r>
-              <a:rPr lang="en-US" sz="2600" dirty="0">
-                <a:solidFill>
-                  <a:srgbClr val="C15943"/>
+              <a:rPr lang="en-US" sz="2799" dirty="0">
+                <a:solidFill>
+                  <a:srgbClr val="571A0E"/>
                 </a:solidFill>
                 <a:latin typeface="Poppins"/>
                 <a:ea typeface="Poppins"/>
@@ -4471,9 +4471,9 @@
               <a:t>, </a:t>
             </a:r>
             <a:r>
-              <a:rPr lang="en-US" sz="2600" dirty="0" err="1">
-                <a:solidFill>
-                  <a:srgbClr val="C15943"/>
+              <a:rPr lang="en-US" sz="2799" dirty="0" err="1">
+                <a:solidFill>
+                  <a:srgbClr val="571A0E"/>
                 </a:solidFill>
                 <a:latin typeface="Poppins"/>
                 <a:ea typeface="Poppins"/>
@@ -4483,9 +4483,9 @@
               <a:t>felis</a:t>
             </a:r>
             <a:r>
-              <a:rPr lang="en-US" sz="2600" dirty="0">
-                <a:solidFill>
-                  <a:srgbClr val="C15943"/>
+              <a:rPr lang="en-US" sz="2799" dirty="0">
+                <a:solidFill>
+                  <a:srgbClr val="571A0E"/>
                 </a:solidFill>
                 <a:latin typeface="Poppins"/>
                 <a:ea typeface="Poppins"/>
@@ -4495,9 +4495,9 @@
               <a:t> dui </a:t>
             </a:r>
             <a:r>
-              <a:rPr lang="en-US" sz="2600" dirty="0" err="1">
-                <a:solidFill>
-                  <a:srgbClr val="C15943"/>
+              <a:rPr lang="en-US" sz="2799" dirty="0" err="1">
+                <a:solidFill>
+                  <a:srgbClr val="571A0E"/>
                 </a:solidFill>
                 <a:latin typeface="Poppins"/>
                 <a:ea typeface="Poppins"/>
@@ -4507,9 +4507,9 @@
               <a:t>suscipit</a:t>
             </a:r>
             <a:r>
-              <a:rPr lang="en-US" sz="2600" dirty="0">
-                <a:solidFill>
-                  <a:srgbClr val="C15943"/>
+              <a:rPr lang="en-US" sz="2799" dirty="0">
+                <a:solidFill>
+                  <a:srgbClr val="571A0E"/>
                 </a:solidFill>
                 <a:latin typeface="Poppins"/>
                 <a:ea typeface="Poppins"/>
@@ -4519,9 +4519,9 @@
               <a:t> </a:t>
             </a:r>
             <a:r>
-              <a:rPr lang="en-US" sz="2600" dirty="0" err="1">
-                <a:solidFill>
-                  <a:srgbClr val="C15943"/>
+              <a:rPr lang="en-US" sz="2799" dirty="0" err="1">
+                <a:solidFill>
+                  <a:srgbClr val="571A0E"/>
                 </a:solidFill>
                 <a:latin typeface="Poppins"/>
                 <a:ea typeface="Poppins"/>
@@ -4531,9 +4531,9 @@
               <a:t>purus</a:t>
             </a:r>
             <a:r>
-              <a:rPr lang="en-US" sz="2600" dirty="0">
-                <a:solidFill>
-                  <a:srgbClr val="C15943"/>
+              <a:rPr lang="en-US" sz="2799" dirty="0">
+                <a:solidFill>
+                  <a:srgbClr val="571A0E"/>
                 </a:solidFill>
                 <a:latin typeface="Poppins"/>
                 <a:ea typeface="Poppins"/>
@@ -4543,9 +4543,9 @@
               <a:t>, a maximus </a:t>
             </a:r>
             <a:r>
-              <a:rPr lang="en-US" sz="2600" dirty="0" err="1">
-                <a:solidFill>
-                  <a:srgbClr val="C15943"/>
+              <a:rPr lang="en-US" sz="2799" dirty="0" err="1">
+                <a:solidFill>
+                  <a:srgbClr val="571A0E"/>
                 </a:solidFill>
                 <a:latin typeface="Poppins"/>
                 <a:ea typeface="Poppins"/>
@@ -4555,9 +4555,9 @@
               <a:t>leo</a:t>
             </a:r>
             <a:r>
-              <a:rPr lang="en-US" sz="2600" dirty="0">
-                <a:solidFill>
-                  <a:srgbClr val="C15943"/>
+              <a:rPr lang="en-US" sz="2799" dirty="0">
+                <a:solidFill>
+                  <a:srgbClr val="571A0E"/>
                 </a:solidFill>
                 <a:latin typeface="Poppins"/>
                 <a:ea typeface="Poppins"/>
@@ -4567,9 +4567,9 @@
               <a:t> ligula at dolor. Morbi et </a:t>
             </a:r>
             <a:r>
-              <a:rPr lang="en-US" sz="2600" dirty="0" err="1">
-                <a:solidFill>
-                  <a:srgbClr val="C15943"/>
+              <a:rPr lang="en-US" sz="2799" dirty="0" err="1">
+                <a:solidFill>
+                  <a:srgbClr val="571A0E"/>
                 </a:solidFill>
                 <a:latin typeface="Poppins"/>
                 <a:ea typeface="Poppins"/>
@@ -4579,9 +4579,9 @@
               <a:t>malesuada</a:t>
             </a:r>
             <a:r>
-              <a:rPr lang="en-US" sz="2600" dirty="0">
-                <a:solidFill>
-                  <a:srgbClr val="C15943"/>
+              <a:rPr lang="en-US" sz="2799" dirty="0">
+                <a:solidFill>
+                  <a:srgbClr val="571A0E"/>
                 </a:solidFill>
                 <a:latin typeface="Poppins"/>
                 <a:ea typeface="Poppins"/>
@@ -4591,9 +4591,9 @@
               <a:t> </a:t>
             </a:r>
             <a:r>
-              <a:rPr lang="en-US" sz="2600" dirty="0" err="1">
-                <a:solidFill>
-                  <a:srgbClr val="C15943"/>
+              <a:rPr lang="en-US" sz="2799" dirty="0" err="1">
+                <a:solidFill>
+                  <a:srgbClr val="571A0E"/>
                 </a:solidFill>
                 <a:latin typeface="Poppins"/>
                 <a:ea typeface="Poppins"/>
@@ -4603,9 +4603,9 @@
               <a:t>purus</a:t>
             </a:r>
             <a:r>
-              <a:rPr lang="en-US" sz="2600" dirty="0">
-                <a:solidFill>
-                  <a:srgbClr val="C15943"/>
+              <a:rPr lang="en-US" sz="2799" dirty="0">
+                <a:solidFill>
+                  <a:srgbClr val="571A0E"/>
                 </a:solidFill>
                 <a:latin typeface="Poppins"/>
                 <a:ea typeface="Poppins"/>
@@ -4615,9 +4615,9 @@
               <a:t>. </a:t>
             </a:r>
             <a:r>
-              <a:rPr lang="en-US" sz="2600" dirty="0" err="1">
-                <a:solidFill>
-                  <a:srgbClr val="C15943"/>
+              <a:rPr lang="en-US" sz="2799" dirty="0" err="1">
+                <a:solidFill>
+                  <a:srgbClr val="571A0E"/>
                 </a:solidFill>
                 <a:latin typeface="Poppins"/>
                 <a:ea typeface="Poppins"/>
@@ -4627,9 +4627,9 @@
               <a:t>Phasellus</a:t>
             </a:r>
             <a:r>
-              <a:rPr lang="en-US" sz="2600" dirty="0">
-                <a:solidFill>
-                  <a:srgbClr val="C15943"/>
+              <a:rPr lang="en-US" sz="2799" dirty="0">
+                <a:solidFill>
+                  <a:srgbClr val="571A0E"/>
                 </a:solidFill>
                 <a:latin typeface="Poppins"/>
                 <a:ea typeface="Poppins"/>
@@ -4639,9 +4639,9 @@
               <a:t> a </a:t>
             </a:r>
             <a:r>
-              <a:rPr lang="en-US" sz="2600" dirty="0" err="1">
-                <a:solidFill>
-                  <a:srgbClr val="C15943"/>
+              <a:rPr lang="en-US" sz="2799" dirty="0" err="1">
+                <a:solidFill>
+                  <a:srgbClr val="571A0E"/>
                 </a:solidFill>
                 <a:latin typeface="Poppins"/>
                 <a:ea typeface="Poppins"/>
@@ -4651,9 +4651,9 @@
               <a:t>lacus</a:t>
             </a:r>
             <a:r>
-              <a:rPr lang="en-US" sz="2600" dirty="0">
-                <a:solidFill>
-                  <a:srgbClr val="C15943"/>
+              <a:rPr lang="en-US" sz="2799" dirty="0">
+                <a:solidFill>
+                  <a:srgbClr val="571A0E"/>
                 </a:solidFill>
                 <a:latin typeface="Poppins"/>
                 <a:ea typeface="Poppins"/>
@@ -4663,9 +4663,9 @@
               <a:t> sit </a:t>
             </a:r>
             <a:r>
-              <a:rPr lang="en-US" sz="2600" dirty="0" err="1">
-                <a:solidFill>
-                  <a:srgbClr val="C15943"/>
+              <a:rPr lang="en-US" sz="2799" dirty="0" err="1">
+                <a:solidFill>
+                  <a:srgbClr val="571A0E"/>
                 </a:solidFill>
                 <a:latin typeface="Poppins"/>
                 <a:ea typeface="Poppins"/>
@@ -4675,9 +4675,9 @@
               <a:t>amet</a:t>
             </a:r>
             <a:r>
-              <a:rPr lang="en-US" sz="2600" dirty="0">
-                <a:solidFill>
-                  <a:srgbClr val="C15943"/>
+              <a:rPr lang="en-US" sz="2799" dirty="0">
+                <a:solidFill>
+                  <a:srgbClr val="571A0E"/>
                 </a:solidFill>
                 <a:latin typeface="Poppins"/>
                 <a:ea typeface="Poppins"/>
@@ -4687,9 +4687,9 @@
               <a:t> </a:t>
             </a:r>
             <a:r>
-              <a:rPr lang="en-US" sz="2600" dirty="0" err="1">
-                <a:solidFill>
-                  <a:srgbClr val="C15943"/>
+              <a:rPr lang="en-US" sz="2799" dirty="0" err="1">
+                <a:solidFill>
+                  <a:srgbClr val="571A0E"/>
                 </a:solidFill>
                 <a:latin typeface="Poppins"/>
                 <a:ea typeface="Poppins"/>
@@ -4699,9 +4699,9 @@
               <a:t>urna</a:t>
             </a:r>
             <a:r>
-              <a:rPr lang="en-US" sz="2600" dirty="0">
-                <a:solidFill>
-                  <a:srgbClr val="C15943"/>
+              <a:rPr lang="en-US" sz="2799" dirty="0">
+                <a:solidFill>
+                  <a:srgbClr val="571A0E"/>
                 </a:solidFill>
                 <a:latin typeface="Poppins"/>
                 <a:ea typeface="Poppins"/>
@@ -4711,9 +4711,9 @@
               <a:t> </a:t>
             </a:r>
             <a:r>
-              <a:rPr lang="en-US" sz="2600" dirty="0" err="1">
-                <a:solidFill>
-                  <a:srgbClr val="C15943"/>
+              <a:rPr lang="en-US" sz="2799" dirty="0" err="1">
+                <a:solidFill>
+                  <a:srgbClr val="571A0E"/>
                 </a:solidFill>
                 <a:latin typeface="Poppins"/>
                 <a:ea typeface="Poppins"/>
@@ -4723,9 +4723,9 @@
               <a:t>tempor</a:t>
             </a:r>
             <a:r>
-              <a:rPr lang="en-US" sz="2600" dirty="0">
-                <a:solidFill>
-                  <a:srgbClr val="C15943"/>
+              <a:rPr lang="en-US" sz="2799" dirty="0">
+                <a:solidFill>
+                  <a:srgbClr val="571A0E"/>
                 </a:solidFill>
                 <a:latin typeface="Poppins"/>
                 <a:ea typeface="Poppins"/>
@@ -4735,9 +4735,9 @@
               <a:t> </a:t>
             </a:r>
             <a:r>
-              <a:rPr lang="en-US" sz="2600" dirty="0" err="1">
-                <a:solidFill>
-                  <a:srgbClr val="C15943"/>
+              <a:rPr lang="en-US" sz="2799" dirty="0" err="1">
+                <a:solidFill>
+                  <a:srgbClr val="571A0E"/>
                 </a:solidFill>
                 <a:latin typeface="Poppins"/>
                 <a:ea typeface="Poppins"/>
@@ -4747,9 +4747,9 @@
               <a:t>sollicitudin</a:t>
             </a:r>
             <a:r>
-              <a:rPr lang="en-US" sz="2600" dirty="0">
-                <a:solidFill>
-                  <a:srgbClr val="C15943"/>
+              <a:rPr lang="en-US" sz="2799" dirty="0">
+                <a:solidFill>
+                  <a:srgbClr val="571A0E"/>
                 </a:solidFill>
                 <a:latin typeface="Poppins"/>
                 <a:ea typeface="Poppins"/>
@@ -4759,9 +4759,9 @@
               <a:t>. Cras </a:t>
             </a:r>
             <a:r>
-              <a:rPr lang="en-US" sz="2600" dirty="0" err="1">
-                <a:solidFill>
-                  <a:srgbClr val="C15943"/>
+              <a:rPr lang="en-US" sz="2799" dirty="0" err="1">
+                <a:solidFill>
+                  <a:srgbClr val="571A0E"/>
                 </a:solidFill>
                 <a:latin typeface="Poppins"/>
                 <a:ea typeface="Poppins"/>
@@ -4771,9 +4771,9 @@
               <a:t>pretium</a:t>
             </a:r>
             <a:r>
-              <a:rPr lang="en-US" sz="2600" dirty="0">
-                <a:solidFill>
-                  <a:srgbClr val="C15943"/>
+              <a:rPr lang="en-US" sz="2799" dirty="0">
+                <a:solidFill>
+                  <a:srgbClr val="571A0E"/>
                 </a:solidFill>
                 <a:latin typeface="Poppins"/>
                 <a:ea typeface="Poppins"/>
@@ -4783,9 +4783,9 @@
               <a:t> </a:t>
             </a:r>
             <a:r>
-              <a:rPr lang="en-US" sz="2600" dirty="0" err="1">
-                <a:solidFill>
-                  <a:srgbClr val="C15943"/>
+              <a:rPr lang="en-US" sz="2799" dirty="0" err="1">
+                <a:solidFill>
+                  <a:srgbClr val="571A0E"/>
                 </a:solidFill>
                 <a:latin typeface="Poppins"/>
                 <a:ea typeface="Poppins"/>
@@ -4795,9 +4795,9 @@
               <a:t>tempor</a:t>
             </a:r>
             <a:r>
-              <a:rPr lang="en-US" sz="2600" dirty="0">
-                <a:solidFill>
-                  <a:srgbClr val="C15943"/>
+              <a:rPr lang="en-US" sz="2799" dirty="0">
+                <a:solidFill>
+                  <a:srgbClr val="571A0E"/>
                 </a:solidFill>
                 <a:latin typeface="Poppins"/>
                 <a:ea typeface="Poppins"/>
@@ -4807,9 +4807,9 @@
               <a:t> </a:t>
             </a:r>
             <a:r>
-              <a:rPr lang="en-US" sz="2600" dirty="0" err="1">
-                <a:solidFill>
-                  <a:srgbClr val="C15943"/>
+              <a:rPr lang="en-US" sz="2799" dirty="0" err="1">
+                <a:solidFill>
+                  <a:srgbClr val="571A0E"/>
                 </a:solidFill>
                 <a:latin typeface="Poppins"/>
                 <a:ea typeface="Poppins"/>
@@ -4819,9 +4819,9 @@
               <a:t>elit</a:t>
             </a:r>
             <a:r>
-              <a:rPr lang="en-US" sz="2600" dirty="0">
-                <a:solidFill>
-                  <a:srgbClr val="C15943"/>
+              <a:rPr lang="en-US" sz="2799" dirty="0">
+                <a:solidFill>
+                  <a:srgbClr val="571A0E"/>
                 </a:solidFill>
                 <a:latin typeface="Poppins"/>
                 <a:ea typeface="Poppins"/>
@@ -4831,9 +4831,9 @@
               <a:t> </a:t>
             </a:r>
             <a:r>
-              <a:rPr lang="en-US" sz="2600" dirty="0" err="1">
-                <a:solidFill>
-                  <a:srgbClr val="C15943"/>
+              <a:rPr lang="en-US" sz="2799" dirty="0" err="1">
+                <a:solidFill>
+                  <a:srgbClr val="571A0E"/>
                 </a:solidFill>
                 <a:latin typeface="Poppins"/>
                 <a:ea typeface="Poppins"/>
@@ -4843,9 +4843,9 @@
               <a:t>blandit</a:t>
             </a:r>
             <a:r>
-              <a:rPr lang="en-US" sz="2600" dirty="0">
-                <a:solidFill>
-                  <a:srgbClr val="C15943"/>
+              <a:rPr lang="en-US" sz="2799" dirty="0">
+                <a:solidFill>
+                  <a:srgbClr val="571A0E"/>
                 </a:solidFill>
                 <a:latin typeface="Poppins"/>
                 <a:ea typeface="Poppins"/>
@@ -4855,9 +4855,9 @@
               <a:t> </a:t>
             </a:r>
             <a:r>
-              <a:rPr lang="en-US" sz="2600" dirty="0" err="1">
-                <a:solidFill>
-                  <a:srgbClr val="C15943"/>
+              <a:rPr lang="en-US" sz="2799" dirty="0" err="1">
+                <a:solidFill>
+                  <a:srgbClr val="571A0E"/>
                 </a:solidFill>
                 <a:latin typeface="Poppins"/>
                 <a:ea typeface="Poppins"/>
@@ -4867,57 +4867,9 @@
               <a:t>egestas</a:t>
             </a:r>
             <a:r>
-              <a:rPr lang="en-US" sz="2600" dirty="0">
-                <a:solidFill>
-                  <a:srgbClr val="C15943"/>
-                </a:solidFill>
-                <a:latin typeface="Poppins"/>
-                <a:ea typeface="Poppins"/>
-                <a:cs typeface="Poppins"/>
-                <a:sym typeface="Poppins"/>
-              </a:rPr>
-              <a:t>. Donec sed </a:t>
-            </a:r>
-            <a:r>
-              <a:rPr lang="en-US" sz="2600" dirty="0" err="1">
-                <a:solidFill>
-                  <a:srgbClr val="C15943"/>
-                </a:solidFill>
-                <a:latin typeface="Poppins"/>
-                <a:ea typeface="Poppins"/>
-                <a:cs typeface="Poppins"/>
-                <a:sym typeface="Poppins"/>
-              </a:rPr>
-              <a:t>dignissim</a:t>
-            </a:r>
-            <a:r>
-              <a:rPr lang="en-US" sz="2600" dirty="0">
-                <a:solidFill>
-                  <a:srgbClr val="C15943"/>
-                </a:solidFill>
-                <a:latin typeface="Poppins"/>
-                <a:ea typeface="Poppins"/>
-                <a:cs typeface="Poppins"/>
-                <a:sym typeface="Poppins"/>
-              </a:rPr>
-              <a:t> </a:t>
-            </a:r>
-            <a:r>
-              <a:rPr lang="en-US" sz="2600" dirty="0" err="1">
-                <a:solidFill>
-                  <a:srgbClr val="C15943"/>
-                </a:solidFill>
-                <a:latin typeface="Poppins"/>
-                <a:ea typeface="Poppins"/>
-                <a:cs typeface="Poppins"/>
-                <a:sym typeface="Poppins"/>
-              </a:rPr>
-              <a:t>augue</a:t>
-            </a:r>
-            <a:r>
-              <a:rPr lang="en-US" sz="2600" dirty="0">
-                <a:solidFill>
-                  <a:srgbClr val="C15943"/>
+              <a:rPr lang="en-US" sz="2799" dirty="0">
+                <a:solidFill>
+                  <a:srgbClr val="571A0E"/>
                 </a:solidFill>
                 <a:latin typeface="Poppins"/>
                 <a:ea typeface="Poppins"/>
@@ -4931,14 +4883,14 @@
       </p:sp>
       <p:sp>
         <p:nvSpPr>
-          <p:cNvPr id="13" name="TextBox 13"/>
+          <p:cNvPr id="10" name="TextBox 10"/>
           <p:cNvSpPr txBox="1"/>
           <p:nvPr/>
         </p:nvSpPr>
         <p:spPr>
           <a:xfrm>
-            <a:off x="5675360" y="647700"/>
-            <a:ext cx="7839034" cy="677108"/>
+            <a:off x="1600200" y="800100"/>
+            <a:ext cx="11784550" cy="677108"/>
           </a:xfrm>
           <a:prstGeom prst="rect">
             <a:avLst/>
@@ -4950,7 +4902,7 @@
           </a:bodyPr>
           <a:lstStyle/>
           <a:p>
-            <a:pPr algn="ctr"/>
+            <a:pPr algn="l"/>
             <a:r>
               <a:rPr lang="en-US" sz="4400" b="1" dirty="0">
                 <a:solidFill>
@@ -4961,7 +4913,7 @@
                 <a:cs typeface="Montaser Arabic Bold"/>
                 <a:sym typeface="Montaser Arabic Bold"/>
               </a:rPr>
-              <a:t>KEY FACTS</a:t>
+              <a:t>QUICK OVERVIEW</a:t>
             </a:r>
           </a:p>
         </p:txBody>
@@ -4974,8 +4926,8 @@
         </p:nvSpPr>
         <p:spPr>
           <a:xfrm>
-            <a:off x="11449408" y="4646676"/>
-            <a:ext cx="4541635" cy="4611624"/>
+            <a:off x="2112436" y="6321598"/>
+            <a:ext cx="9537552" cy="2328672"/>
           </a:xfrm>
           <a:prstGeom prst="rect">
             <a:avLst/>
@@ -4989,20 +4941,20 @@
           <a:p>
             <a:pPr algn="l">
               <a:lnSpc>
-                <a:spcPts val="2808"/>
+                <a:spcPts val="3023"/>
               </a:lnSpc>
             </a:pPr>
             <a:r>
-              <a:rPr lang="en-US" sz="2600">
-                <a:solidFill>
-                  <a:srgbClr val="C15943"/>
-                </a:solidFill>
-                <a:latin typeface="Poppins"/>
-                <a:ea typeface="Poppins"/>
-                <a:cs typeface="Poppins"/>
-                <a:sym typeface="Poppins"/>
-              </a:rPr>
-              <a:t>Lorem ipsum dolor sit amet, consectetur adipiscing elit. Quisque non elit mauris. Cras euismod, metus ac finibus finibus, felis dui suscipit purus, a maximus leo ligula at dolor. Morbi et malesuada purus. Phasellus a lacus sit amet urna tempor sollicitudin. Cras pretium tempor elit blandit egestas. Donec sed dignissim augue.</a:t>
+              <a:rPr lang="en-US" sz="2799">
+                <a:solidFill>
+                  <a:srgbClr val="571A0E"/>
+                </a:solidFill>
+                <a:latin typeface="Poppins"/>
+                <a:ea typeface="Poppins"/>
+                <a:cs typeface="Poppins"/>
+                <a:sym typeface="Poppins"/>
+              </a:rPr>
+              <a:t>Lorem ipsum dolor sit amet, consectetur adipiscing elit. Quisque non elit mauris. Cras euismod, metus ac finibus finibus, felis dui suscipit purus, a maximus leo ligula at dolor. Morbi et malesuada purus. Phasellus a lacus sit amet urna tempor sollicitudin. Cras pretium tempor elit blandit egestas.</a:t>
             </a:r>
           </a:p>
         </p:txBody>
@@ -5054,8 +5006,8 @@
         </p:nvSpPr>
         <p:spPr>
           <a:xfrm>
-            <a:off x="5913075" y="3318314"/>
-            <a:ext cx="5577822" cy="2709672"/>
+            <a:off x="5640947" y="4562143"/>
+            <a:ext cx="4541635" cy="4611624"/>
           </a:xfrm>
           <a:prstGeom prst="rect">
             <a:avLst/>
@@ -5069,20 +5021,740 @@
           <a:p>
             <a:pPr algn="l">
               <a:lnSpc>
-                <a:spcPts val="3023"/>
+                <a:spcPts val="2808"/>
               </a:lnSpc>
             </a:pPr>
             <a:r>
-              <a:rPr lang="en-US" sz="2799">
-                <a:solidFill>
-                  <a:srgbClr val="C15943"/>
-                </a:solidFill>
-                <a:latin typeface="Poppins"/>
-                <a:ea typeface="Poppins"/>
-                <a:cs typeface="Poppins"/>
-                <a:sym typeface="Poppins"/>
-              </a:rPr>
-              <a:t>Lorem ipsum dolor sit amet, consectetur adipiscing elit. Quisque non elit mauris. Cras euismod, metus ac finibus finibus, felis dui suscipit purus, a maximus leo ligula at dolor. Morbi et malesuada purus.</a:t>
+              <a:rPr lang="en-US" sz="2600" dirty="0">
+                <a:solidFill>
+                  <a:srgbClr val="C15943"/>
+                </a:solidFill>
+                <a:latin typeface="Poppins"/>
+                <a:ea typeface="Poppins"/>
+                <a:cs typeface="Poppins"/>
+                <a:sym typeface="Poppins"/>
+              </a:rPr>
+              <a:t>Lorem ipsum dolor sit </a:t>
+            </a:r>
+            <a:r>
+              <a:rPr lang="en-US" sz="2600" dirty="0" err="1">
+                <a:solidFill>
+                  <a:srgbClr val="C15943"/>
+                </a:solidFill>
+                <a:latin typeface="Poppins"/>
+                <a:ea typeface="Poppins"/>
+                <a:cs typeface="Poppins"/>
+                <a:sym typeface="Poppins"/>
+              </a:rPr>
+              <a:t>amet</a:t>
+            </a:r>
+            <a:r>
+              <a:rPr lang="en-US" sz="2600" dirty="0">
+                <a:solidFill>
+                  <a:srgbClr val="C15943"/>
+                </a:solidFill>
+                <a:latin typeface="Poppins"/>
+                <a:ea typeface="Poppins"/>
+                <a:cs typeface="Poppins"/>
+                <a:sym typeface="Poppins"/>
+              </a:rPr>
+              <a:t>, </a:t>
+            </a:r>
+            <a:r>
+              <a:rPr lang="en-US" sz="2600" dirty="0" err="1">
+                <a:solidFill>
+                  <a:srgbClr val="C15943"/>
+                </a:solidFill>
+                <a:latin typeface="Poppins"/>
+                <a:ea typeface="Poppins"/>
+                <a:cs typeface="Poppins"/>
+                <a:sym typeface="Poppins"/>
+              </a:rPr>
+              <a:t>consectetur</a:t>
+            </a:r>
+            <a:r>
+              <a:rPr lang="en-US" sz="2600" dirty="0">
+                <a:solidFill>
+                  <a:srgbClr val="C15943"/>
+                </a:solidFill>
+                <a:latin typeface="Poppins"/>
+                <a:ea typeface="Poppins"/>
+                <a:cs typeface="Poppins"/>
+                <a:sym typeface="Poppins"/>
+              </a:rPr>
+              <a:t> </a:t>
+            </a:r>
+            <a:r>
+              <a:rPr lang="en-US" sz="2600" dirty="0" err="1">
+                <a:solidFill>
+                  <a:srgbClr val="C15943"/>
+                </a:solidFill>
+                <a:latin typeface="Poppins"/>
+                <a:ea typeface="Poppins"/>
+                <a:cs typeface="Poppins"/>
+                <a:sym typeface="Poppins"/>
+              </a:rPr>
+              <a:t>adipiscing</a:t>
+            </a:r>
+            <a:r>
+              <a:rPr lang="en-US" sz="2600" dirty="0">
+                <a:solidFill>
+                  <a:srgbClr val="C15943"/>
+                </a:solidFill>
+                <a:latin typeface="Poppins"/>
+                <a:ea typeface="Poppins"/>
+                <a:cs typeface="Poppins"/>
+                <a:sym typeface="Poppins"/>
+              </a:rPr>
+              <a:t> </a:t>
+            </a:r>
+            <a:r>
+              <a:rPr lang="en-US" sz="2600" dirty="0" err="1">
+                <a:solidFill>
+                  <a:srgbClr val="C15943"/>
+                </a:solidFill>
+                <a:latin typeface="Poppins"/>
+                <a:ea typeface="Poppins"/>
+                <a:cs typeface="Poppins"/>
+                <a:sym typeface="Poppins"/>
+              </a:rPr>
+              <a:t>elit</a:t>
+            </a:r>
+            <a:r>
+              <a:rPr lang="en-US" sz="2600" dirty="0">
+                <a:solidFill>
+                  <a:srgbClr val="C15943"/>
+                </a:solidFill>
+                <a:latin typeface="Poppins"/>
+                <a:ea typeface="Poppins"/>
+                <a:cs typeface="Poppins"/>
+                <a:sym typeface="Poppins"/>
+              </a:rPr>
+              <a:t>. </a:t>
+            </a:r>
+            <a:r>
+              <a:rPr lang="en-US" sz="2600" dirty="0" err="1">
+                <a:solidFill>
+                  <a:srgbClr val="C15943"/>
+                </a:solidFill>
+                <a:latin typeface="Poppins"/>
+                <a:ea typeface="Poppins"/>
+                <a:cs typeface="Poppins"/>
+                <a:sym typeface="Poppins"/>
+              </a:rPr>
+              <a:t>Quisque</a:t>
+            </a:r>
+            <a:r>
+              <a:rPr lang="en-US" sz="2600" dirty="0">
+                <a:solidFill>
+                  <a:srgbClr val="C15943"/>
+                </a:solidFill>
+                <a:latin typeface="Poppins"/>
+                <a:ea typeface="Poppins"/>
+                <a:cs typeface="Poppins"/>
+                <a:sym typeface="Poppins"/>
+              </a:rPr>
+              <a:t> non </a:t>
+            </a:r>
+            <a:r>
+              <a:rPr lang="en-US" sz="2600" dirty="0" err="1">
+                <a:solidFill>
+                  <a:srgbClr val="C15943"/>
+                </a:solidFill>
+                <a:latin typeface="Poppins"/>
+                <a:ea typeface="Poppins"/>
+                <a:cs typeface="Poppins"/>
+                <a:sym typeface="Poppins"/>
+              </a:rPr>
+              <a:t>elit</a:t>
+            </a:r>
+            <a:r>
+              <a:rPr lang="en-US" sz="2600" dirty="0">
+                <a:solidFill>
+                  <a:srgbClr val="C15943"/>
+                </a:solidFill>
+                <a:latin typeface="Poppins"/>
+                <a:ea typeface="Poppins"/>
+                <a:cs typeface="Poppins"/>
+                <a:sym typeface="Poppins"/>
+              </a:rPr>
+              <a:t> </a:t>
+            </a:r>
+            <a:r>
+              <a:rPr lang="en-US" sz="2600" dirty="0" err="1">
+                <a:solidFill>
+                  <a:srgbClr val="C15943"/>
+                </a:solidFill>
+                <a:latin typeface="Poppins"/>
+                <a:ea typeface="Poppins"/>
+                <a:cs typeface="Poppins"/>
+                <a:sym typeface="Poppins"/>
+              </a:rPr>
+              <a:t>mauris</a:t>
+            </a:r>
+            <a:r>
+              <a:rPr lang="en-US" sz="2600" dirty="0">
+                <a:solidFill>
+                  <a:srgbClr val="C15943"/>
+                </a:solidFill>
+                <a:latin typeface="Poppins"/>
+                <a:ea typeface="Poppins"/>
+                <a:cs typeface="Poppins"/>
+                <a:sym typeface="Poppins"/>
+              </a:rPr>
+              <a:t>. Cras </a:t>
+            </a:r>
+            <a:r>
+              <a:rPr lang="en-US" sz="2600" dirty="0" err="1">
+                <a:solidFill>
+                  <a:srgbClr val="C15943"/>
+                </a:solidFill>
+                <a:latin typeface="Poppins"/>
+                <a:ea typeface="Poppins"/>
+                <a:cs typeface="Poppins"/>
+                <a:sym typeface="Poppins"/>
+              </a:rPr>
+              <a:t>euismod</a:t>
+            </a:r>
+            <a:r>
+              <a:rPr lang="en-US" sz="2600" dirty="0">
+                <a:solidFill>
+                  <a:srgbClr val="C15943"/>
+                </a:solidFill>
+                <a:latin typeface="Poppins"/>
+                <a:ea typeface="Poppins"/>
+                <a:cs typeface="Poppins"/>
+                <a:sym typeface="Poppins"/>
+              </a:rPr>
+              <a:t>, </a:t>
+            </a:r>
+            <a:r>
+              <a:rPr lang="en-US" sz="2600" dirty="0" err="1">
+                <a:solidFill>
+                  <a:srgbClr val="C15943"/>
+                </a:solidFill>
+                <a:latin typeface="Poppins"/>
+                <a:ea typeface="Poppins"/>
+                <a:cs typeface="Poppins"/>
+                <a:sym typeface="Poppins"/>
+              </a:rPr>
+              <a:t>metus</a:t>
+            </a:r>
+            <a:r>
+              <a:rPr lang="en-US" sz="2600" dirty="0">
+                <a:solidFill>
+                  <a:srgbClr val="C15943"/>
+                </a:solidFill>
+                <a:latin typeface="Poppins"/>
+                <a:ea typeface="Poppins"/>
+                <a:cs typeface="Poppins"/>
+                <a:sym typeface="Poppins"/>
+              </a:rPr>
+              <a:t> ac </a:t>
+            </a:r>
+            <a:r>
+              <a:rPr lang="en-US" sz="2600" dirty="0" err="1">
+                <a:solidFill>
+                  <a:srgbClr val="C15943"/>
+                </a:solidFill>
+                <a:latin typeface="Poppins"/>
+                <a:ea typeface="Poppins"/>
+                <a:cs typeface="Poppins"/>
+                <a:sym typeface="Poppins"/>
+              </a:rPr>
+              <a:t>finibus</a:t>
+            </a:r>
+            <a:r>
+              <a:rPr lang="en-US" sz="2600" dirty="0">
+                <a:solidFill>
+                  <a:srgbClr val="C15943"/>
+                </a:solidFill>
+                <a:latin typeface="Poppins"/>
+                <a:ea typeface="Poppins"/>
+                <a:cs typeface="Poppins"/>
+                <a:sym typeface="Poppins"/>
+              </a:rPr>
+              <a:t> </a:t>
+            </a:r>
+            <a:r>
+              <a:rPr lang="en-US" sz="2600" dirty="0" err="1">
+                <a:solidFill>
+                  <a:srgbClr val="C15943"/>
+                </a:solidFill>
+                <a:latin typeface="Poppins"/>
+                <a:ea typeface="Poppins"/>
+                <a:cs typeface="Poppins"/>
+                <a:sym typeface="Poppins"/>
+              </a:rPr>
+              <a:t>finibus</a:t>
+            </a:r>
+            <a:r>
+              <a:rPr lang="en-US" sz="2600" dirty="0">
+                <a:solidFill>
+                  <a:srgbClr val="C15943"/>
+                </a:solidFill>
+                <a:latin typeface="Poppins"/>
+                <a:ea typeface="Poppins"/>
+                <a:cs typeface="Poppins"/>
+                <a:sym typeface="Poppins"/>
+              </a:rPr>
+              <a:t>, </a:t>
+            </a:r>
+            <a:r>
+              <a:rPr lang="en-US" sz="2600" dirty="0" err="1">
+                <a:solidFill>
+                  <a:srgbClr val="C15943"/>
+                </a:solidFill>
+                <a:latin typeface="Poppins"/>
+                <a:ea typeface="Poppins"/>
+                <a:cs typeface="Poppins"/>
+                <a:sym typeface="Poppins"/>
+              </a:rPr>
+              <a:t>felis</a:t>
+            </a:r>
+            <a:r>
+              <a:rPr lang="en-US" sz="2600" dirty="0">
+                <a:solidFill>
+                  <a:srgbClr val="C15943"/>
+                </a:solidFill>
+                <a:latin typeface="Poppins"/>
+                <a:ea typeface="Poppins"/>
+                <a:cs typeface="Poppins"/>
+                <a:sym typeface="Poppins"/>
+              </a:rPr>
+              <a:t> dui </a:t>
+            </a:r>
+            <a:r>
+              <a:rPr lang="en-US" sz="2600" dirty="0" err="1">
+                <a:solidFill>
+                  <a:srgbClr val="C15943"/>
+                </a:solidFill>
+                <a:latin typeface="Poppins"/>
+                <a:ea typeface="Poppins"/>
+                <a:cs typeface="Poppins"/>
+                <a:sym typeface="Poppins"/>
+              </a:rPr>
+              <a:t>suscipit</a:t>
+            </a:r>
+            <a:r>
+              <a:rPr lang="en-US" sz="2600" dirty="0">
+                <a:solidFill>
+                  <a:srgbClr val="C15943"/>
+                </a:solidFill>
+                <a:latin typeface="Poppins"/>
+                <a:ea typeface="Poppins"/>
+                <a:cs typeface="Poppins"/>
+                <a:sym typeface="Poppins"/>
+              </a:rPr>
+              <a:t> </a:t>
+            </a:r>
+            <a:r>
+              <a:rPr lang="en-US" sz="2600" dirty="0" err="1">
+                <a:solidFill>
+                  <a:srgbClr val="C15943"/>
+                </a:solidFill>
+                <a:latin typeface="Poppins"/>
+                <a:ea typeface="Poppins"/>
+                <a:cs typeface="Poppins"/>
+                <a:sym typeface="Poppins"/>
+              </a:rPr>
+              <a:t>purus</a:t>
+            </a:r>
+            <a:r>
+              <a:rPr lang="en-US" sz="2600" dirty="0">
+                <a:solidFill>
+                  <a:srgbClr val="C15943"/>
+                </a:solidFill>
+                <a:latin typeface="Poppins"/>
+                <a:ea typeface="Poppins"/>
+                <a:cs typeface="Poppins"/>
+                <a:sym typeface="Poppins"/>
+              </a:rPr>
+              <a:t>, a maximus </a:t>
+            </a:r>
+            <a:r>
+              <a:rPr lang="en-US" sz="2600" dirty="0" err="1">
+                <a:solidFill>
+                  <a:srgbClr val="C15943"/>
+                </a:solidFill>
+                <a:latin typeface="Poppins"/>
+                <a:ea typeface="Poppins"/>
+                <a:cs typeface="Poppins"/>
+                <a:sym typeface="Poppins"/>
+              </a:rPr>
+              <a:t>leo</a:t>
+            </a:r>
+            <a:r>
+              <a:rPr lang="en-US" sz="2600" dirty="0">
+                <a:solidFill>
+                  <a:srgbClr val="C15943"/>
+                </a:solidFill>
+                <a:latin typeface="Poppins"/>
+                <a:ea typeface="Poppins"/>
+                <a:cs typeface="Poppins"/>
+                <a:sym typeface="Poppins"/>
+              </a:rPr>
+              <a:t> ligula at dolor. Morbi et </a:t>
+            </a:r>
+            <a:r>
+              <a:rPr lang="en-US" sz="2600" dirty="0" err="1">
+                <a:solidFill>
+                  <a:srgbClr val="C15943"/>
+                </a:solidFill>
+                <a:latin typeface="Poppins"/>
+                <a:ea typeface="Poppins"/>
+                <a:cs typeface="Poppins"/>
+                <a:sym typeface="Poppins"/>
+              </a:rPr>
+              <a:t>malesuada</a:t>
+            </a:r>
+            <a:r>
+              <a:rPr lang="en-US" sz="2600" dirty="0">
+                <a:solidFill>
+                  <a:srgbClr val="C15943"/>
+                </a:solidFill>
+                <a:latin typeface="Poppins"/>
+                <a:ea typeface="Poppins"/>
+                <a:cs typeface="Poppins"/>
+                <a:sym typeface="Poppins"/>
+              </a:rPr>
+              <a:t> </a:t>
+            </a:r>
+            <a:r>
+              <a:rPr lang="en-US" sz="2600" dirty="0" err="1">
+                <a:solidFill>
+                  <a:srgbClr val="C15943"/>
+                </a:solidFill>
+                <a:latin typeface="Poppins"/>
+                <a:ea typeface="Poppins"/>
+                <a:cs typeface="Poppins"/>
+                <a:sym typeface="Poppins"/>
+              </a:rPr>
+              <a:t>purus</a:t>
+            </a:r>
+            <a:r>
+              <a:rPr lang="en-US" sz="2600" dirty="0">
+                <a:solidFill>
+                  <a:srgbClr val="C15943"/>
+                </a:solidFill>
+                <a:latin typeface="Poppins"/>
+                <a:ea typeface="Poppins"/>
+                <a:cs typeface="Poppins"/>
+                <a:sym typeface="Poppins"/>
+              </a:rPr>
+              <a:t>. </a:t>
+            </a:r>
+            <a:r>
+              <a:rPr lang="en-US" sz="2600" dirty="0" err="1">
+                <a:solidFill>
+                  <a:srgbClr val="C15943"/>
+                </a:solidFill>
+                <a:latin typeface="Poppins"/>
+                <a:ea typeface="Poppins"/>
+                <a:cs typeface="Poppins"/>
+                <a:sym typeface="Poppins"/>
+              </a:rPr>
+              <a:t>Phasellus</a:t>
+            </a:r>
+            <a:r>
+              <a:rPr lang="en-US" sz="2600" dirty="0">
+                <a:solidFill>
+                  <a:srgbClr val="C15943"/>
+                </a:solidFill>
+                <a:latin typeface="Poppins"/>
+                <a:ea typeface="Poppins"/>
+                <a:cs typeface="Poppins"/>
+                <a:sym typeface="Poppins"/>
+              </a:rPr>
+              <a:t> a </a:t>
+            </a:r>
+            <a:r>
+              <a:rPr lang="en-US" sz="2600" dirty="0" err="1">
+                <a:solidFill>
+                  <a:srgbClr val="C15943"/>
+                </a:solidFill>
+                <a:latin typeface="Poppins"/>
+                <a:ea typeface="Poppins"/>
+                <a:cs typeface="Poppins"/>
+                <a:sym typeface="Poppins"/>
+              </a:rPr>
+              <a:t>lacus</a:t>
+            </a:r>
+            <a:r>
+              <a:rPr lang="en-US" sz="2600" dirty="0">
+                <a:solidFill>
+                  <a:srgbClr val="C15943"/>
+                </a:solidFill>
+                <a:latin typeface="Poppins"/>
+                <a:ea typeface="Poppins"/>
+                <a:cs typeface="Poppins"/>
+                <a:sym typeface="Poppins"/>
+              </a:rPr>
+              <a:t> sit </a:t>
+            </a:r>
+            <a:r>
+              <a:rPr lang="en-US" sz="2600" dirty="0" err="1">
+                <a:solidFill>
+                  <a:srgbClr val="C15943"/>
+                </a:solidFill>
+                <a:latin typeface="Poppins"/>
+                <a:ea typeface="Poppins"/>
+                <a:cs typeface="Poppins"/>
+                <a:sym typeface="Poppins"/>
+              </a:rPr>
+              <a:t>amet</a:t>
+            </a:r>
+            <a:r>
+              <a:rPr lang="en-US" sz="2600" dirty="0">
+                <a:solidFill>
+                  <a:srgbClr val="C15943"/>
+                </a:solidFill>
+                <a:latin typeface="Poppins"/>
+                <a:ea typeface="Poppins"/>
+                <a:cs typeface="Poppins"/>
+                <a:sym typeface="Poppins"/>
+              </a:rPr>
+              <a:t> </a:t>
+            </a:r>
+            <a:r>
+              <a:rPr lang="en-US" sz="2600" dirty="0" err="1">
+                <a:solidFill>
+                  <a:srgbClr val="C15943"/>
+                </a:solidFill>
+                <a:latin typeface="Poppins"/>
+                <a:ea typeface="Poppins"/>
+                <a:cs typeface="Poppins"/>
+                <a:sym typeface="Poppins"/>
+              </a:rPr>
+              <a:t>urna</a:t>
+            </a:r>
+            <a:r>
+              <a:rPr lang="en-US" sz="2600" dirty="0">
+                <a:solidFill>
+                  <a:srgbClr val="C15943"/>
+                </a:solidFill>
+                <a:latin typeface="Poppins"/>
+                <a:ea typeface="Poppins"/>
+                <a:cs typeface="Poppins"/>
+                <a:sym typeface="Poppins"/>
+              </a:rPr>
+              <a:t> </a:t>
+            </a:r>
+            <a:r>
+              <a:rPr lang="en-US" sz="2600" dirty="0" err="1">
+                <a:solidFill>
+                  <a:srgbClr val="C15943"/>
+                </a:solidFill>
+                <a:latin typeface="Poppins"/>
+                <a:ea typeface="Poppins"/>
+                <a:cs typeface="Poppins"/>
+                <a:sym typeface="Poppins"/>
+              </a:rPr>
+              <a:t>tempor</a:t>
+            </a:r>
+            <a:r>
+              <a:rPr lang="en-US" sz="2600" dirty="0">
+                <a:solidFill>
+                  <a:srgbClr val="C15943"/>
+                </a:solidFill>
+                <a:latin typeface="Poppins"/>
+                <a:ea typeface="Poppins"/>
+                <a:cs typeface="Poppins"/>
+                <a:sym typeface="Poppins"/>
+              </a:rPr>
+              <a:t> </a:t>
+            </a:r>
+            <a:r>
+              <a:rPr lang="en-US" sz="2600" dirty="0" err="1">
+                <a:solidFill>
+                  <a:srgbClr val="C15943"/>
+                </a:solidFill>
+                <a:latin typeface="Poppins"/>
+                <a:ea typeface="Poppins"/>
+                <a:cs typeface="Poppins"/>
+                <a:sym typeface="Poppins"/>
+              </a:rPr>
+              <a:t>sollicitudin</a:t>
+            </a:r>
+            <a:r>
+              <a:rPr lang="en-US" sz="2600" dirty="0">
+                <a:solidFill>
+                  <a:srgbClr val="C15943"/>
+                </a:solidFill>
+                <a:latin typeface="Poppins"/>
+                <a:ea typeface="Poppins"/>
+                <a:cs typeface="Poppins"/>
+                <a:sym typeface="Poppins"/>
+              </a:rPr>
+              <a:t>. Cras </a:t>
+            </a:r>
+            <a:r>
+              <a:rPr lang="en-US" sz="2600" dirty="0" err="1">
+                <a:solidFill>
+                  <a:srgbClr val="C15943"/>
+                </a:solidFill>
+                <a:latin typeface="Poppins"/>
+                <a:ea typeface="Poppins"/>
+                <a:cs typeface="Poppins"/>
+                <a:sym typeface="Poppins"/>
+              </a:rPr>
+              <a:t>pretium</a:t>
+            </a:r>
+            <a:r>
+              <a:rPr lang="en-US" sz="2600" dirty="0">
+                <a:solidFill>
+                  <a:srgbClr val="C15943"/>
+                </a:solidFill>
+                <a:latin typeface="Poppins"/>
+                <a:ea typeface="Poppins"/>
+                <a:cs typeface="Poppins"/>
+                <a:sym typeface="Poppins"/>
+              </a:rPr>
+              <a:t> </a:t>
+            </a:r>
+            <a:r>
+              <a:rPr lang="en-US" sz="2600" dirty="0" err="1">
+                <a:solidFill>
+                  <a:srgbClr val="C15943"/>
+                </a:solidFill>
+                <a:latin typeface="Poppins"/>
+                <a:ea typeface="Poppins"/>
+                <a:cs typeface="Poppins"/>
+                <a:sym typeface="Poppins"/>
+              </a:rPr>
+              <a:t>tempor</a:t>
+            </a:r>
+            <a:r>
+              <a:rPr lang="en-US" sz="2600" dirty="0">
+                <a:solidFill>
+                  <a:srgbClr val="C15943"/>
+                </a:solidFill>
+                <a:latin typeface="Poppins"/>
+                <a:ea typeface="Poppins"/>
+                <a:cs typeface="Poppins"/>
+                <a:sym typeface="Poppins"/>
+              </a:rPr>
+              <a:t> </a:t>
+            </a:r>
+            <a:r>
+              <a:rPr lang="en-US" sz="2600" dirty="0" err="1">
+                <a:solidFill>
+                  <a:srgbClr val="C15943"/>
+                </a:solidFill>
+                <a:latin typeface="Poppins"/>
+                <a:ea typeface="Poppins"/>
+                <a:cs typeface="Poppins"/>
+                <a:sym typeface="Poppins"/>
+              </a:rPr>
+              <a:t>elit</a:t>
+            </a:r>
+            <a:r>
+              <a:rPr lang="en-US" sz="2600" dirty="0">
+                <a:solidFill>
+                  <a:srgbClr val="C15943"/>
+                </a:solidFill>
+                <a:latin typeface="Poppins"/>
+                <a:ea typeface="Poppins"/>
+                <a:cs typeface="Poppins"/>
+                <a:sym typeface="Poppins"/>
+              </a:rPr>
+              <a:t> </a:t>
+            </a:r>
+            <a:r>
+              <a:rPr lang="en-US" sz="2600" dirty="0" err="1">
+                <a:solidFill>
+                  <a:srgbClr val="C15943"/>
+                </a:solidFill>
+                <a:latin typeface="Poppins"/>
+                <a:ea typeface="Poppins"/>
+                <a:cs typeface="Poppins"/>
+                <a:sym typeface="Poppins"/>
+              </a:rPr>
+              <a:t>blandit</a:t>
+            </a:r>
+            <a:r>
+              <a:rPr lang="en-US" sz="2600" dirty="0">
+                <a:solidFill>
+                  <a:srgbClr val="C15943"/>
+                </a:solidFill>
+                <a:latin typeface="Poppins"/>
+                <a:ea typeface="Poppins"/>
+                <a:cs typeface="Poppins"/>
+                <a:sym typeface="Poppins"/>
+              </a:rPr>
+              <a:t> </a:t>
+            </a:r>
+            <a:r>
+              <a:rPr lang="en-US" sz="2600" dirty="0" err="1">
+                <a:solidFill>
+                  <a:srgbClr val="C15943"/>
+                </a:solidFill>
+                <a:latin typeface="Poppins"/>
+                <a:ea typeface="Poppins"/>
+                <a:cs typeface="Poppins"/>
+                <a:sym typeface="Poppins"/>
+              </a:rPr>
+              <a:t>egestas</a:t>
+            </a:r>
+            <a:r>
+              <a:rPr lang="en-US" sz="2600" dirty="0">
+                <a:solidFill>
+                  <a:srgbClr val="C15943"/>
+                </a:solidFill>
+                <a:latin typeface="Poppins"/>
+                <a:ea typeface="Poppins"/>
+                <a:cs typeface="Poppins"/>
+                <a:sym typeface="Poppins"/>
+              </a:rPr>
+              <a:t>. Donec sed </a:t>
+            </a:r>
+            <a:r>
+              <a:rPr lang="en-US" sz="2600" dirty="0" err="1">
+                <a:solidFill>
+                  <a:srgbClr val="C15943"/>
+                </a:solidFill>
+                <a:latin typeface="Poppins"/>
+                <a:ea typeface="Poppins"/>
+                <a:cs typeface="Poppins"/>
+                <a:sym typeface="Poppins"/>
+              </a:rPr>
+              <a:t>dignissim</a:t>
+            </a:r>
+            <a:r>
+              <a:rPr lang="en-US" sz="2600" dirty="0">
+                <a:solidFill>
+                  <a:srgbClr val="C15943"/>
+                </a:solidFill>
+                <a:latin typeface="Poppins"/>
+                <a:ea typeface="Poppins"/>
+                <a:cs typeface="Poppins"/>
+                <a:sym typeface="Poppins"/>
+              </a:rPr>
+              <a:t> </a:t>
+            </a:r>
+            <a:r>
+              <a:rPr lang="en-US" sz="2600" dirty="0" err="1">
+                <a:solidFill>
+                  <a:srgbClr val="C15943"/>
+                </a:solidFill>
+                <a:latin typeface="Poppins"/>
+                <a:ea typeface="Poppins"/>
+                <a:cs typeface="Poppins"/>
+                <a:sym typeface="Poppins"/>
+              </a:rPr>
+              <a:t>augue</a:t>
+            </a:r>
+            <a:r>
+              <a:rPr lang="en-US" sz="2600" dirty="0">
+                <a:solidFill>
+                  <a:srgbClr val="C15943"/>
+                </a:solidFill>
+                <a:latin typeface="Poppins"/>
+                <a:ea typeface="Poppins"/>
+                <a:cs typeface="Poppins"/>
+                <a:sym typeface="Poppins"/>
+              </a:rPr>
+              <a:t>.</a:t>
             </a:r>
           </a:p>
         </p:txBody>
@@ -5095,8 +5767,8 @@
         </p:nvSpPr>
         <p:spPr>
           <a:xfrm>
-            <a:off x="3308129" y="571667"/>
-            <a:ext cx="11671742" cy="677108"/>
+            <a:off x="5675360" y="647700"/>
+            <a:ext cx="7839034" cy="677108"/>
           </a:xfrm>
           <a:prstGeom prst="rect">
             <a:avLst/>
@@ -5108,7 +5780,7 @@
           </a:bodyPr>
           <a:lstStyle/>
           <a:p>
-            <a:pPr algn="l"/>
+            <a:pPr algn="ctr"/>
             <a:r>
               <a:rPr lang="en-US" sz="4400" b="1" dirty="0">
                 <a:solidFill>
@@ -5119,7 +5791,7 @@
                 <a:cs typeface="Montaser Arabic Bold"/>
                 <a:sym typeface="Montaser Arabic Bold"/>
               </a:rPr>
-              <a:t>IMPORTANT INSIGHTS</a:t>
+              <a:t>KEY FACTS</a:t>
             </a:r>
           </a:p>
         </p:txBody>
@@ -5132,8 +5804,8 @@
         </p:nvSpPr>
         <p:spPr>
           <a:xfrm>
-            <a:off x="5913075" y="6340852"/>
-            <a:ext cx="5577822" cy="2709672"/>
+            <a:off x="11449408" y="4646676"/>
+            <a:ext cx="4541635" cy="4611624"/>
           </a:xfrm>
           <a:prstGeom prst="rect">
             <a:avLst/>
@@ -5147,20 +5819,20 @@
           <a:p>
             <a:pPr algn="l">
               <a:lnSpc>
-                <a:spcPts val="3023"/>
+                <a:spcPts val="2808"/>
               </a:lnSpc>
             </a:pPr>
             <a:r>
-              <a:rPr lang="en-US" sz="2799">
-                <a:solidFill>
-                  <a:srgbClr val="C15943"/>
-                </a:solidFill>
-                <a:latin typeface="Poppins"/>
-                <a:ea typeface="Poppins"/>
-                <a:cs typeface="Poppins"/>
-                <a:sym typeface="Poppins"/>
-              </a:rPr>
-              <a:t>Lorem ipsum dolor sit amet, consectetur adipiscing elit. Quisque non elit mauris. Cras euismod, metus ac finibus finibus, felis dui suscipit purus, a maximus leo ligula at dolor. Morbi et malesuada purus.</a:t>
+              <a:rPr lang="en-US" sz="2600">
+                <a:solidFill>
+                  <a:srgbClr val="C15943"/>
+                </a:solidFill>
+                <a:latin typeface="Poppins"/>
+                <a:ea typeface="Poppins"/>
+                <a:cs typeface="Poppins"/>
+                <a:sym typeface="Poppins"/>
+              </a:rPr>
+              <a:t>Lorem ipsum dolor sit amet, consectetur adipiscing elit. Quisque non elit mauris. Cras euismod, metus ac finibus finibus, felis dui suscipit purus, a maximus leo ligula at dolor. Morbi et malesuada purus. Phasellus a lacus sit amet urna tempor sollicitudin. Cras pretium tempor elit blandit egestas. Donec sed dignissim augue.</a:t>
             </a:r>
           </a:p>
         </p:txBody>
@@ -5206,13 +5878,579 @@
       </p:grpSpPr>
       <p:sp>
         <p:nvSpPr>
+          <p:cNvPr id="12" name="TextBox 12"/>
+          <p:cNvSpPr txBox="1"/>
+          <p:nvPr/>
+        </p:nvSpPr>
+        <p:spPr>
+          <a:xfrm>
+            <a:off x="5913075" y="3318314"/>
+            <a:ext cx="5577822" cy="2709672"/>
+          </a:xfrm>
+          <a:prstGeom prst="rect">
+            <a:avLst/>
+          </a:prstGeom>
+        </p:spPr>
+        <p:txBody>
+          <a:bodyPr lIns="0" tIns="0" rIns="0" bIns="0" rtlCol="0" anchor="t">
+            <a:spAutoFit/>
+          </a:bodyPr>
+          <a:lstStyle/>
+          <a:p>
+            <a:pPr algn="l">
+              <a:lnSpc>
+                <a:spcPts val="3023"/>
+              </a:lnSpc>
+            </a:pPr>
+            <a:r>
+              <a:rPr lang="en-US" sz="2799" dirty="0">
+                <a:solidFill>
+                  <a:srgbClr val="C15943"/>
+                </a:solidFill>
+                <a:latin typeface="Poppins"/>
+                <a:ea typeface="Poppins"/>
+                <a:cs typeface="Poppins"/>
+                <a:sym typeface="Poppins"/>
+              </a:rPr>
+              <a:t>Lorem ipsum dolor sit </a:t>
+            </a:r>
+            <a:r>
+              <a:rPr lang="en-US" sz="2799" dirty="0" err="1">
+                <a:solidFill>
+                  <a:srgbClr val="C15943"/>
+                </a:solidFill>
+                <a:latin typeface="Poppins"/>
+                <a:ea typeface="Poppins"/>
+                <a:cs typeface="Poppins"/>
+                <a:sym typeface="Poppins"/>
+              </a:rPr>
+              <a:t>amet</a:t>
+            </a:r>
+            <a:r>
+              <a:rPr lang="en-US" sz="2799" dirty="0">
+                <a:solidFill>
+                  <a:srgbClr val="C15943"/>
+                </a:solidFill>
+                <a:latin typeface="Poppins"/>
+                <a:ea typeface="Poppins"/>
+                <a:cs typeface="Poppins"/>
+                <a:sym typeface="Poppins"/>
+              </a:rPr>
+              <a:t>, </a:t>
+            </a:r>
+            <a:r>
+              <a:rPr lang="en-US" sz="2799" dirty="0" err="1">
+                <a:solidFill>
+                  <a:srgbClr val="C15943"/>
+                </a:solidFill>
+                <a:latin typeface="Poppins"/>
+                <a:ea typeface="Poppins"/>
+                <a:cs typeface="Poppins"/>
+                <a:sym typeface="Poppins"/>
+              </a:rPr>
+              <a:t>consectetur</a:t>
+            </a:r>
+            <a:r>
+              <a:rPr lang="en-US" sz="2799" dirty="0">
+                <a:solidFill>
+                  <a:srgbClr val="C15943"/>
+                </a:solidFill>
+                <a:latin typeface="Poppins"/>
+                <a:ea typeface="Poppins"/>
+                <a:cs typeface="Poppins"/>
+                <a:sym typeface="Poppins"/>
+              </a:rPr>
+              <a:t> </a:t>
+            </a:r>
+            <a:r>
+              <a:rPr lang="en-US" sz="2799" dirty="0" err="1">
+                <a:solidFill>
+                  <a:srgbClr val="C15943"/>
+                </a:solidFill>
+                <a:latin typeface="Poppins"/>
+                <a:ea typeface="Poppins"/>
+                <a:cs typeface="Poppins"/>
+                <a:sym typeface="Poppins"/>
+              </a:rPr>
+              <a:t>adipiscing</a:t>
+            </a:r>
+            <a:r>
+              <a:rPr lang="en-US" sz="2799" dirty="0">
+                <a:solidFill>
+                  <a:srgbClr val="C15943"/>
+                </a:solidFill>
+                <a:latin typeface="Poppins"/>
+                <a:ea typeface="Poppins"/>
+                <a:cs typeface="Poppins"/>
+                <a:sym typeface="Poppins"/>
+              </a:rPr>
+              <a:t> </a:t>
+            </a:r>
+            <a:r>
+              <a:rPr lang="en-US" sz="2799" dirty="0" err="1">
+                <a:solidFill>
+                  <a:srgbClr val="C15943"/>
+                </a:solidFill>
+                <a:latin typeface="Poppins"/>
+                <a:ea typeface="Poppins"/>
+                <a:cs typeface="Poppins"/>
+                <a:sym typeface="Poppins"/>
+              </a:rPr>
+              <a:t>elit</a:t>
+            </a:r>
+            <a:r>
+              <a:rPr lang="en-US" sz="2799" dirty="0">
+                <a:solidFill>
+                  <a:srgbClr val="C15943"/>
+                </a:solidFill>
+                <a:latin typeface="Poppins"/>
+                <a:ea typeface="Poppins"/>
+                <a:cs typeface="Poppins"/>
+                <a:sym typeface="Poppins"/>
+              </a:rPr>
+              <a:t>. </a:t>
+            </a:r>
+            <a:r>
+              <a:rPr lang="en-US" sz="2799" dirty="0" err="1">
+                <a:solidFill>
+                  <a:srgbClr val="C15943"/>
+                </a:solidFill>
+                <a:latin typeface="Poppins"/>
+                <a:ea typeface="Poppins"/>
+                <a:cs typeface="Poppins"/>
+                <a:sym typeface="Poppins"/>
+              </a:rPr>
+              <a:t>Quisque</a:t>
+            </a:r>
+            <a:r>
+              <a:rPr lang="en-US" sz="2799" dirty="0">
+                <a:solidFill>
+                  <a:srgbClr val="C15943"/>
+                </a:solidFill>
+                <a:latin typeface="Poppins"/>
+                <a:ea typeface="Poppins"/>
+                <a:cs typeface="Poppins"/>
+                <a:sym typeface="Poppins"/>
+              </a:rPr>
+              <a:t> non </a:t>
+            </a:r>
+            <a:r>
+              <a:rPr lang="en-US" sz="2799" dirty="0" err="1">
+                <a:solidFill>
+                  <a:srgbClr val="C15943"/>
+                </a:solidFill>
+                <a:latin typeface="Poppins"/>
+                <a:ea typeface="Poppins"/>
+                <a:cs typeface="Poppins"/>
+                <a:sym typeface="Poppins"/>
+              </a:rPr>
+              <a:t>elit</a:t>
+            </a:r>
+            <a:r>
+              <a:rPr lang="en-US" sz="2799" dirty="0">
+                <a:solidFill>
+                  <a:srgbClr val="C15943"/>
+                </a:solidFill>
+                <a:latin typeface="Poppins"/>
+                <a:ea typeface="Poppins"/>
+                <a:cs typeface="Poppins"/>
+                <a:sym typeface="Poppins"/>
+              </a:rPr>
+              <a:t> </a:t>
+            </a:r>
+            <a:r>
+              <a:rPr lang="en-US" sz="2799" dirty="0" err="1">
+                <a:solidFill>
+                  <a:srgbClr val="C15943"/>
+                </a:solidFill>
+                <a:latin typeface="Poppins"/>
+                <a:ea typeface="Poppins"/>
+                <a:cs typeface="Poppins"/>
+                <a:sym typeface="Poppins"/>
+              </a:rPr>
+              <a:t>mauris</a:t>
+            </a:r>
+            <a:r>
+              <a:rPr lang="en-US" sz="2799" dirty="0">
+                <a:solidFill>
+                  <a:srgbClr val="C15943"/>
+                </a:solidFill>
+                <a:latin typeface="Poppins"/>
+                <a:ea typeface="Poppins"/>
+                <a:cs typeface="Poppins"/>
+                <a:sym typeface="Poppins"/>
+              </a:rPr>
+              <a:t>. Cras </a:t>
+            </a:r>
+            <a:r>
+              <a:rPr lang="en-US" sz="2799" dirty="0" err="1">
+                <a:solidFill>
+                  <a:srgbClr val="C15943"/>
+                </a:solidFill>
+                <a:latin typeface="Poppins"/>
+                <a:ea typeface="Poppins"/>
+                <a:cs typeface="Poppins"/>
+                <a:sym typeface="Poppins"/>
+              </a:rPr>
+              <a:t>euismod</a:t>
+            </a:r>
+            <a:r>
+              <a:rPr lang="en-US" sz="2799" dirty="0">
+                <a:solidFill>
+                  <a:srgbClr val="C15943"/>
+                </a:solidFill>
+                <a:latin typeface="Poppins"/>
+                <a:ea typeface="Poppins"/>
+                <a:cs typeface="Poppins"/>
+                <a:sym typeface="Poppins"/>
+              </a:rPr>
+              <a:t>, </a:t>
+            </a:r>
+            <a:r>
+              <a:rPr lang="en-US" sz="2799" dirty="0" err="1">
+                <a:solidFill>
+                  <a:srgbClr val="C15943"/>
+                </a:solidFill>
+                <a:latin typeface="Poppins"/>
+                <a:ea typeface="Poppins"/>
+                <a:cs typeface="Poppins"/>
+                <a:sym typeface="Poppins"/>
+              </a:rPr>
+              <a:t>metus</a:t>
+            </a:r>
+            <a:r>
+              <a:rPr lang="en-US" sz="2799" dirty="0">
+                <a:solidFill>
+                  <a:srgbClr val="C15943"/>
+                </a:solidFill>
+                <a:latin typeface="Poppins"/>
+                <a:ea typeface="Poppins"/>
+                <a:cs typeface="Poppins"/>
+                <a:sym typeface="Poppins"/>
+              </a:rPr>
+              <a:t> ac </a:t>
+            </a:r>
+            <a:r>
+              <a:rPr lang="en-US" sz="2799" dirty="0" err="1">
+                <a:solidFill>
+                  <a:srgbClr val="C15943"/>
+                </a:solidFill>
+                <a:latin typeface="Poppins"/>
+                <a:ea typeface="Poppins"/>
+                <a:cs typeface="Poppins"/>
+                <a:sym typeface="Poppins"/>
+              </a:rPr>
+              <a:t>finibus</a:t>
+            </a:r>
+            <a:r>
+              <a:rPr lang="en-US" sz="2799" dirty="0">
+                <a:solidFill>
+                  <a:srgbClr val="C15943"/>
+                </a:solidFill>
+                <a:latin typeface="Poppins"/>
+                <a:ea typeface="Poppins"/>
+                <a:cs typeface="Poppins"/>
+                <a:sym typeface="Poppins"/>
+              </a:rPr>
+              <a:t> </a:t>
+            </a:r>
+            <a:r>
+              <a:rPr lang="en-US" sz="2799" dirty="0" err="1">
+                <a:solidFill>
+                  <a:srgbClr val="C15943"/>
+                </a:solidFill>
+                <a:latin typeface="Poppins"/>
+                <a:ea typeface="Poppins"/>
+                <a:cs typeface="Poppins"/>
+                <a:sym typeface="Poppins"/>
+              </a:rPr>
+              <a:t>finibus</a:t>
+            </a:r>
+            <a:r>
+              <a:rPr lang="en-US" sz="2799" dirty="0">
+                <a:solidFill>
+                  <a:srgbClr val="C15943"/>
+                </a:solidFill>
+                <a:latin typeface="Poppins"/>
+                <a:ea typeface="Poppins"/>
+                <a:cs typeface="Poppins"/>
+                <a:sym typeface="Poppins"/>
+              </a:rPr>
+              <a:t>, </a:t>
+            </a:r>
+            <a:r>
+              <a:rPr lang="en-US" sz="2799" dirty="0" err="1">
+                <a:solidFill>
+                  <a:srgbClr val="C15943"/>
+                </a:solidFill>
+                <a:latin typeface="Poppins"/>
+                <a:ea typeface="Poppins"/>
+                <a:cs typeface="Poppins"/>
+                <a:sym typeface="Poppins"/>
+              </a:rPr>
+              <a:t>felis</a:t>
+            </a:r>
+            <a:r>
+              <a:rPr lang="en-US" sz="2799" dirty="0">
+                <a:solidFill>
+                  <a:srgbClr val="C15943"/>
+                </a:solidFill>
+                <a:latin typeface="Poppins"/>
+                <a:ea typeface="Poppins"/>
+                <a:cs typeface="Poppins"/>
+                <a:sym typeface="Poppins"/>
+              </a:rPr>
+              <a:t> dui </a:t>
+            </a:r>
+            <a:r>
+              <a:rPr lang="en-US" sz="2799" dirty="0" err="1">
+                <a:solidFill>
+                  <a:srgbClr val="C15943"/>
+                </a:solidFill>
+                <a:latin typeface="Poppins"/>
+                <a:ea typeface="Poppins"/>
+                <a:cs typeface="Poppins"/>
+                <a:sym typeface="Poppins"/>
+              </a:rPr>
+              <a:t>suscipit</a:t>
+            </a:r>
+            <a:r>
+              <a:rPr lang="en-US" sz="2799" dirty="0">
+                <a:solidFill>
+                  <a:srgbClr val="C15943"/>
+                </a:solidFill>
+                <a:latin typeface="Poppins"/>
+                <a:ea typeface="Poppins"/>
+                <a:cs typeface="Poppins"/>
+                <a:sym typeface="Poppins"/>
+              </a:rPr>
+              <a:t> </a:t>
+            </a:r>
+            <a:r>
+              <a:rPr lang="en-US" sz="2799" dirty="0" err="1">
+                <a:solidFill>
+                  <a:srgbClr val="C15943"/>
+                </a:solidFill>
+                <a:latin typeface="Poppins"/>
+                <a:ea typeface="Poppins"/>
+                <a:cs typeface="Poppins"/>
+                <a:sym typeface="Poppins"/>
+              </a:rPr>
+              <a:t>purus</a:t>
+            </a:r>
+            <a:r>
+              <a:rPr lang="en-US" sz="2799" dirty="0">
+                <a:solidFill>
+                  <a:srgbClr val="C15943"/>
+                </a:solidFill>
+                <a:latin typeface="Poppins"/>
+                <a:ea typeface="Poppins"/>
+                <a:cs typeface="Poppins"/>
+                <a:sym typeface="Poppins"/>
+              </a:rPr>
+              <a:t>, a maximus </a:t>
+            </a:r>
+            <a:r>
+              <a:rPr lang="en-US" sz="2799" dirty="0" err="1">
+                <a:solidFill>
+                  <a:srgbClr val="C15943"/>
+                </a:solidFill>
+                <a:latin typeface="Poppins"/>
+                <a:ea typeface="Poppins"/>
+                <a:cs typeface="Poppins"/>
+                <a:sym typeface="Poppins"/>
+              </a:rPr>
+              <a:t>leo</a:t>
+            </a:r>
+            <a:r>
+              <a:rPr lang="en-US" sz="2799" dirty="0">
+                <a:solidFill>
+                  <a:srgbClr val="C15943"/>
+                </a:solidFill>
+                <a:latin typeface="Poppins"/>
+                <a:ea typeface="Poppins"/>
+                <a:cs typeface="Poppins"/>
+                <a:sym typeface="Poppins"/>
+              </a:rPr>
+              <a:t> ligula at dolor. Morbi et </a:t>
+            </a:r>
+            <a:r>
+              <a:rPr lang="en-US" sz="2799" dirty="0" err="1">
+                <a:solidFill>
+                  <a:srgbClr val="C15943"/>
+                </a:solidFill>
+                <a:latin typeface="Poppins"/>
+                <a:ea typeface="Poppins"/>
+                <a:cs typeface="Poppins"/>
+                <a:sym typeface="Poppins"/>
+              </a:rPr>
+              <a:t>malesuada</a:t>
+            </a:r>
+            <a:r>
+              <a:rPr lang="en-US" sz="2799" dirty="0">
+                <a:solidFill>
+                  <a:srgbClr val="C15943"/>
+                </a:solidFill>
+                <a:latin typeface="Poppins"/>
+                <a:ea typeface="Poppins"/>
+                <a:cs typeface="Poppins"/>
+                <a:sym typeface="Poppins"/>
+              </a:rPr>
+              <a:t> </a:t>
+            </a:r>
+            <a:r>
+              <a:rPr lang="en-US" sz="2799" dirty="0" err="1">
+                <a:solidFill>
+                  <a:srgbClr val="C15943"/>
+                </a:solidFill>
+                <a:latin typeface="Poppins"/>
+                <a:ea typeface="Poppins"/>
+                <a:cs typeface="Poppins"/>
+                <a:sym typeface="Poppins"/>
+              </a:rPr>
+              <a:t>purus</a:t>
+            </a:r>
+            <a:r>
+              <a:rPr lang="en-US" sz="2799" dirty="0">
+                <a:solidFill>
+                  <a:srgbClr val="C15943"/>
+                </a:solidFill>
+                <a:latin typeface="Poppins"/>
+                <a:ea typeface="Poppins"/>
+                <a:cs typeface="Poppins"/>
+                <a:sym typeface="Poppins"/>
+              </a:rPr>
+              <a:t>.</a:t>
+            </a:r>
+          </a:p>
+        </p:txBody>
+      </p:sp>
+      <p:sp>
+        <p:nvSpPr>
+          <p:cNvPr id="13" name="TextBox 13"/>
+          <p:cNvSpPr txBox="1"/>
+          <p:nvPr/>
+        </p:nvSpPr>
+        <p:spPr>
+          <a:xfrm>
+            <a:off x="3308129" y="571667"/>
+            <a:ext cx="11671742" cy="677108"/>
+          </a:xfrm>
+          <a:prstGeom prst="rect">
+            <a:avLst/>
+          </a:prstGeom>
+        </p:spPr>
+        <p:txBody>
+          <a:bodyPr lIns="0" tIns="0" rIns="0" bIns="0" rtlCol="0" anchor="t">
+            <a:spAutoFit/>
+          </a:bodyPr>
+          <a:lstStyle/>
+          <a:p>
+            <a:pPr algn="l"/>
+            <a:r>
+              <a:rPr lang="en-US" sz="4400" b="1" dirty="0">
+                <a:solidFill>
+                  <a:srgbClr val="C15943"/>
+                </a:solidFill>
+                <a:latin typeface="Montaser Arabic Bold"/>
+                <a:ea typeface="Montaser Arabic Bold"/>
+                <a:cs typeface="Montaser Arabic Bold"/>
+                <a:sym typeface="Montaser Arabic Bold"/>
+              </a:rPr>
+              <a:t>IMPORTANT INSIGHTS</a:t>
+            </a:r>
+          </a:p>
+        </p:txBody>
+      </p:sp>
+      <p:sp>
+        <p:nvSpPr>
+          <p:cNvPr id="15" name="TextBox 15"/>
+          <p:cNvSpPr txBox="1"/>
+          <p:nvPr/>
+        </p:nvSpPr>
+        <p:spPr>
+          <a:xfrm>
+            <a:off x="5913075" y="6340852"/>
+            <a:ext cx="5577822" cy="2709672"/>
+          </a:xfrm>
+          <a:prstGeom prst="rect">
+            <a:avLst/>
+          </a:prstGeom>
+        </p:spPr>
+        <p:txBody>
+          <a:bodyPr lIns="0" tIns="0" rIns="0" bIns="0" rtlCol="0" anchor="t">
+            <a:spAutoFit/>
+          </a:bodyPr>
+          <a:lstStyle/>
+          <a:p>
+            <a:pPr algn="l">
+              <a:lnSpc>
+                <a:spcPts val="3023"/>
+              </a:lnSpc>
+            </a:pPr>
+            <a:r>
+              <a:rPr lang="en-US" sz="2799">
+                <a:solidFill>
+                  <a:srgbClr val="C15943"/>
+                </a:solidFill>
+                <a:latin typeface="Poppins"/>
+                <a:ea typeface="Poppins"/>
+                <a:cs typeface="Poppins"/>
+                <a:sym typeface="Poppins"/>
+              </a:rPr>
+              <a:t>Lorem ipsum dolor sit amet, consectetur adipiscing elit. Quisque non elit mauris. Cras euismod, metus ac finibus finibus, felis dui suscipit purus, a maximus leo ligula at dolor. Morbi et malesuada purus.</a:t>
+            </a:r>
+          </a:p>
+        </p:txBody>
+      </p:sp>
+    </p:spTree>
+  </p:cSld>
+  <p:clrMapOvr>
+    <a:masterClrMapping/>
+  </p:clrMapOvr>
+</p:sld>
+</file>
+
+<file path=ppt/slides/slide6.xml><?xml version="1.0" encoding="utf-8"?>
+<p:sld xmlns:a="http://schemas.openxmlformats.org/drawingml/2006/main" xmlns:r="http://schemas.openxmlformats.org/officeDocument/2006/relationships" xmlns:p="http://schemas.openxmlformats.org/presentationml/2006/main">
+  <p:cSld>
+    <p:bg>
+      <p:bgPr>
+        <a:blipFill dpi="0" rotWithShape="1">
+          <a:blip r:embed="rId2">
+            <a:lum/>
+          </a:blip>
+          <a:srcRect/>
+          <a:stretch>
+            <a:fillRect/>
+          </a:stretch>
+        </a:blipFill>
+        <a:effectLst/>
+      </p:bgPr>
+    </p:bg>
+    <p:spTree>
+      <p:nvGrpSpPr>
+        <p:cNvPr id="1" name=""/>
+        <p:cNvGrpSpPr/>
+        <p:nvPr/>
+      </p:nvGrpSpPr>
+      <p:grpSpPr>
+        <a:xfrm>
+          <a:off x="0" y="0"/>
+          <a:ext cx="0" cy="0"/>
+          <a:chOff x="0" y="0"/>
+          <a:chExt cx="0" cy="0"/>
+        </a:xfrm>
+      </p:grpSpPr>
+      <p:sp>
+        <p:nvSpPr>
           <p:cNvPr id="8" name="Freeform 8"/>
           <p:cNvSpPr/>
           <p:nvPr/>
         </p:nvSpPr>
         <p:spPr>
           <a:xfrm>
-            <a:off x="9608076" y="3418324"/>
+            <a:off x="9585449" y="3418324"/>
             <a:ext cx="6698724" cy="5838617"/>
           </a:xfrm>
           <a:custGeom>
@@ -5411,880 +6649,16 @@
               </a:lnSpc>
             </a:pPr>
             <a:r>
-              <a:rPr lang="en-US" sz="2799" dirty="0">
-                <a:solidFill>
-                  <a:srgbClr val="C15943"/>
-                </a:solidFill>
-                <a:latin typeface="Poppins"/>
-                <a:ea typeface="Poppins"/>
-                <a:cs typeface="Poppins"/>
-                <a:sym typeface="Poppins"/>
-              </a:rPr>
-              <a:t>Lorem ipsum dolor sit </a:t>
-            </a:r>
-            <a:r>
-              <a:rPr lang="en-US" sz="2799" dirty="0" err="1">
-                <a:solidFill>
-                  <a:srgbClr val="C15943"/>
-                </a:solidFill>
-                <a:latin typeface="Poppins"/>
-                <a:ea typeface="Poppins"/>
-                <a:cs typeface="Poppins"/>
-                <a:sym typeface="Poppins"/>
-              </a:rPr>
-              <a:t>amet</a:t>
-            </a:r>
-            <a:r>
-              <a:rPr lang="en-US" sz="2799" dirty="0">
-                <a:solidFill>
-                  <a:srgbClr val="C15943"/>
-                </a:solidFill>
-                <a:latin typeface="Poppins"/>
-                <a:ea typeface="Poppins"/>
-                <a:cs typeface="Poppins"/>
-                <a:sym typeface="Poppins"/>
-              </a:rPr>
-              <a:t>, </a:t>
-            </a:r>
-            <a:r>
-              <a:rPr lang="en-US" sz="2799" dirty="0" err="1">
-                <a:solidFill>
-                  <a:srgbClr val="C15943"/>
-                </a:solidFill>
-                <a:latin typeface="Poppins"/>
-                <a:ea typeface="Poppins"/>
-                <a:cs typeface="Poppins"/>
-                <a:sym typeface="Poppins"/>
-              </a:rPr>
-              <a:t>consectetur</a:t>
-            </a:r>
-            <a:r>
-              <a:rPr lang="en-US" sz="2799" dirty="0">
-                <a:solidFill>
-                  <a:srgbClr val="C15943"/>
-                </a:solidFill>
-                <a:latin typeface="Poppins"/>
-                <a:ea typeface="Poppins"/>
-                <a:cs typeface="Poppins"/>
-                <a:sym typeface="Poppins"/>
-              </a:rPr>
-              <a:t> </a:t>
-            </a:r>
-            <a:r>
-              <a:rPr lang="en-US" sz="2799" dirty="0" err="1">
-                <a:solidFill>
-                  <a:srgbClr val="C15943"/>
-                </a:solidFill>
-                <a:latin typeface="Poppins"/>
-                <a:ea typeface="Poppins"/>
-                <a:cs typeface="Poppins"/>
-                <a:sym typeface="Poppins"/>
-              </a:rPr>
-              <a:t>adipiscing</a:t>
-            </a:r>
-            <a:r>
-              <a:rPr lang="en-US" sz="2799" dirty="0">
-                <a:solidFill>
-                  <a:srgbClr val="C15943"/>
-                </a:solidFill>
-                <a:latin typeface="Poppins"/>
-                <a:ea typeface="Poppins"/>
-                <a:cs typeface="Poppins"/>
-                <a:sym typeface="Poppins"/>
-              </a:rPr>
-              <a:t> </a:t>
-            </a:r>
-            <a:r>
-              <a:rPr lang="en-US" sz="2799" dirty="0" err="1">
-                <a:solidFill>
-                  <a:srgbClr val="C15943"/>
-                </a:solidFill>
-                <a:latin typeface="Poppins"/>
-                <a:ea typeface="Poppins"/>
-                <a:cs typeface="Poppins"/>
-                <a:sym typeface="Poppins"/>
-              </a:rPr>
-              <a:t>elit</a:t>
-            </a:r>
-            <a:r>
-              <a:rPr lang="en-US" sz="2799" dirty="0">
-                <a:solidFill>
-                  <a:srgbClr val="C15943"/>
-                </a:solidFill>
-                <a:latin typeface="Poppins"/>
-                <a:ea typeface="Poppins"/>
-                <a:cs typeface="Poppins"/>
-                <a:sym typeface="Poppins"/>
-              </a:rPr>
-              <a:t>. </a:t>
-            </a:r>
-            <a:r>
-              <a:rPr lang="en-US" sz="2799" dirty="0" err="1">
-                <a:solidFill>
-                  <a:srgbClr val="C15943"/>
-                </a:solidFill>
-                <a:latin typeface="Poppins"/>
-                <a:ea typeface="Poppins"/>
-                <a:cs typeface="Poppins"/>
-                <a:sym typeface="Poppins"/>
-              </a:rPr>
-              <a:t>Quisque</a:t>
-            </a:r>
-            <a:r>
-              <a:rPr lang="en-US" sz="2799" dirty="0">
-                <a:solidFill>
-                  <a:srgbClr val="C15943"/>
-                </a:solidFill>
-                <a:latin typeface="Poppins"/>
-                <a:ea typeface="Poppins"/>
-                <a:cs typeface="Poppins"/>
-                <a:sym typeface="Poppins"/>
-              </a:rPr>
-              <a:t> non </a:t>
-            </a:r>
-            <a:r>
-              <a:rPr lang="en-US" sz="2799" dirty="0" err="1">
-                <a:solidFill>
-                  <a:srgbClr val="C15943"/>
-                </a:solidFill>
-                <a:latin typeface="Poppins"/>
-                <a:ea typeface="Poppins"/>
-                <a:cs typeface="Poppins"/>
-                <a:sym typeface="Poppins"/>
-              </a:rPr>
-              <a:t>elit</a:t>
-            </a:r>
-            <a:r>
-              <a:rPr lang="en-US" sz="2799" dirty="0">
-                <a:solidFill>
-                  <a:srgbClr val="C15943"/>
-                </a:solidFill>
-                <a:latin typeface="Poppins"/>
-                <a:ea typeface="Poppins"/>
-                <a:cs typeface="Poppins"/>
-                <a:sym typeface="Poppins"/>
-              </a:rPr>
-              <a:t> </a:t>
-            </a:r>
-            <a:r>
-              <a:rPr lang="en-US" sz="2799" dirty="0" err="1">
-                <a:solidFill>
-                  <a:srgbClr val="C15943"/>
-                </a:solidFill>
-                <a:latin typeface="Poppins"/>
-                <a:ea typeface="Poppins"/>
-                <a:cs typeface="Poppins"/>
-                <a:sym typeface="Poppins"/>
-              </a:rPr>
-              <a:t>mauris</a:t>
-            </a:r>
-            <a:r>
-              <a:rPr lang="en-US" sz="2799" dirty="0">
-                <a:solidFill>
-                  <a:srgbClr val="C15943"/>
-                </a:solidFill>
-                <a:latin typeface="Poppins"/>
-                <a:ea typeface="Poppins"/>
-                <a:cs typeface="Poppins"/>
-                <a:sym typeface="Poppins"/>
-              </a:rPr>
-              <a:t>. Cras </a:t>
-            </a:r>
-            <a:r>
-              <a:rPr lang="en-US" sz="2799" dirty="0" err="1">
-                <a:solidFill>
-                  <a:srgbClr val="C15943"/>
-                </a:solidFill>
-                <a:latin typeface="Poppins"/>
-                <a:ea typeface="Poppins"/>
-                <a:cs typeface="Poppins"/>
-                <a:sym typeface="Poppins"/>
-              </a:rPr>
-              <a:t>euismod</a:t>
-            </a:r>
-            <a:r>
-              <a:rPr lang="en-US" sz="2799" dirty="0">
-                <a:solidFill>
-                  <a:srgbClr val="C15943"/>
-                </a:solidFill>
-                <a:latin typeface="Poppins"/>
-                <a:ea typeface="Poppins"/>
-                <a:cs typeface="Poppins"/>
-                <a:sym typeface="Poppins"/>
-              </a:rPr>
-              <a:t>, </a:t>
-            </a:r>
-            <a:r>
-              <a:rPr lang="en-US" sz="2799" dirty="0" err="1">
-                <a:solidFill>
-                  <a:srgbClr val="C15943"/>
-                </a:solidFill>
-                <a:latin typeface="Poppins"/>
-                <a:ea typeface="Poppins"/>
-                <a:cs typeface="Poppins"/>
-                <a:sym typeface="Poppins"/>
-              </a:rPr>
-              <a:t>metus</a:t>
-            </a:r>
-            <a:r>
-              <a:rPr lang="en-US" sz="2799" dirty="0">
-                <a:solidFill>
-                  <a:srgbClr val="C15943"/>
-                </a:solidFill>
-                <a:latin typeface="Poppins"/>
-                <a:ea typeface="Poppins"/>
-                <a:cs typeface="Poppins"/>
-                <a:sym typeface="Poppins"/>
-              </a:rPr>
-              <a:t> ac </a:t>
-            </a:r>
-            <a:r>
-              <a:rPr lang="en-US" sz="2799" dirty="0" err="1">
-                <a:solidFill>
-                  <a:srgbClr val="C15943"/>
-                </a:solidFill>
-                <a:latin typeface="Poppins"/>
-                <a:ea typeface="Poppins"/>
-                <a:cs typeface="Poppins"/>
-                <a:sym typeface="Poppins"/>
-              </a:rPr>
-              <a:t>finibus</a:t>
-            </a:r>
-            <a:r>
-              <a:rPr lang="en-US" sz="2799" dirty="0">
-                <a:solidFill>
-                  <a:srgbClr val="C15943"/>
-                </a:solidFill>
-                <a:latin typeface="Poppins"/>
-                <a:ea typeface="Poppins"/>
-                <a:cs typeface="Poppins"/>
-                <a:sym typeface="Poppins"/>
-              </a:rPr>
-              <a:t> </a:t>
-            </a:r>
-            <a:r>
-              <a:rPr lang="en-US" sz="2799" dirty="0" err="1">
-                <a:solidFill>
-                  <a:srgbClr val="C15943"/>
-                </a:solidFill>
-                <a:latin typeface="Poppins"/>
-                <a:ea typeface="Poppins"/>
-                <a:cs typeface="Poppins"/>
-                <a:sym typeface="Poppins"/>
-              </a:rPr>
-              <a:t>finibus</a:t>
-            </a:r>
-            <a:r>
-              <a:rPr lang="en-US" sz="2799" dirty="0">
-                <a:solidFill>
-                  <a:srgbClr val="C15943"/>
-                </a:solidFill>
-                <a:latin typeface="Poppins"/>
-                <a:ea typeface="Poppins"/>
-                <a:cs typeface="Poppins"/>
-                <a:sym typeface="Poppins"/>
-              </a:rPr>
-              <a:t>, </a:t>
-            </a:r>
-            <a:r>
-              <a:rPr lang="en-US" sz="2799" dirty="0" err="1">
-                <a:solidFill>
-                  <a:srgbClr val="C15943"/>
-                </a:solidFill>
-                <a:latin typeface="Poppins"/>
-                <a:ea typeface="Poppins"/>
-                <a:cs typeface="Poppins"/>
-                <a:sym typeface="Poppins"/>
-              </a:rPr>
-              <a:t>felis</a:t>
-            </a:r>
-            <a:r>
-              <a:rPr lang="en-US" sz="2799" dirty="0">
-                <a:solidFill>
-                  <a:srgbClr val="C15943"/>
-                </a:solidFill>
-                <a:latin typeface="Poppins"/>
-                <a:ea typeface="Poppins"/>
-                <a:cs typeface="Poppins"/>
-                <a:sym typeface="Poppins"/>
-              </a:rPr>
-              <a:t> dui </a:t>
-            </a:r>
-            <a:r>
-              <a:rPr lang="en-US" sz="2799" dirty="0" err="1">
-                <a:solidFill>
-                  <a:srgbClr val="C15943"/>
-                </a:solidFill>
-                <a:latin typeface="Poppins"/>
-                <a:ea typeface="Poppins"/>
-                <a:cs typeface="Poppins"/>
-                <a:sym typeface="Poppins"/>
-              </a:rPr>
-              <a:t>suscipit</a:t>
-            </a:r>
-            <a:r>
-              <a:rPr lang="en-US" sz="2799" dirty="0">
-                <a:solidFill>
-                  <a:srgbClr val="C15943"/>
-                </a:solidFill>
-                <a:latin typeface="Poppins"/>
-                <a:ea typeface="Poppins"/>
-                <a:cs typeface="Poppins"/>
-                <a:sym typeface="Poppins"/>
-              </a:rPr>
-              <a:t> </a:t>
-            </a:r>
-            <a:r>
-              <a:rPr lang="en-US" sz="2799" dirty="0" err="1">
-                <a:solidFill>
-                  <a:srgbClr val="C15943"/>
-                </a:solidFill>
-                <a:latin typeface="Poppins"/>
-                <a:ea typeface="Poppins"/>
-                <a:cs typeface="Poppins"/>
-                <a:sym typeface="Poppins"/>
-              </a:rPr>
-              <a:t>purus</a:t>
-            </a:r>
-            <a:r>
-              <a:rPr lang="en-US" sz="2799" dirty="0">
-                <a:solidFill>
-                  <a:srgbClr val="C15943"/>
-                </a:solidFill>
-                <a:latin typeface="Poppins"/>
-                <a:ea typeface="Poppins"/>
-                <a:cs typeface="Poppins"/>
-                <a:sym typeface="Poppins"/>
-              </a:rPr>
-              <a:t>, a maximus </a:t>
-            </a:r>
-            <a:r>
-              <a:rPr lang="en-US" sz="2799" dirty="0" err="1">
-                <a:solidFill>
-                  <a:srgbClr val="C15943"/>
-                </a:solidFill>
-                <a:latin typeface="Poppins"/>
-                <a:ea typeface="Poppins"/>
-                <a:cs typeface="Poppins"/>
-                <a:sym typeface="Poppins"/>
-              </a:rPr>
-              <a:t>leo</a:t>
-            </a:r>
-            <a:r>
-              <a:rPr lang="en-US" sz="2799" dirty="0">
-                <a:solidFill>
-                  <a:srgbClr val="C15943"/>
-                </a:solidFill>
-                <a:latin typeface="Poppins"/>
-                <a:ea typeface="Poppins"/>
-                <a:cs typeface="Poppins"/>
-                <a:sym typeface="Poppins"/>
-              </a:rPr>
-              <a:t> ligula at dolor. Morbi et </a:t>
-            </a:r>
-            <a:r>
-              <a:rPr lang="en-US" sz="2799" dirty="0" err="1">
-                <a:solidFill>
-                  <a:srgbClr val="C15943"/>
-                </a:solidFill>
-                <a:latin typeface="Poppins"/>
-                <a:ea typeface="Poppins"/>
-                <a:cs typeface="Poppins"/>
-                <a:sym typeface="Poppins"/>
-              </a:rPr>
-              <a:t>malesuada</a:t>
-            </a:r>
-            <a:r>
-              <a:rPr lang="en-US" sz="2799" dirty="0">
-                <a:solidFill>
-                  <a:srgbClr val="C15943"/>
-                </a:solidFill>
-                <a:latin typeface="Poppins"/>
-                <a:ea typeface="Poppins"/>
-                <a:cs typeface="Poppins"/>
-                <a:sym typeface="Poppins"/>
-              </a:rPr>
-              <a:t> </a:t>
-            </a:r>
-            <a:r>
-              <a:rPr lang="en-US" sz="2799" dirty="0" err="1">
-                <a:solidFill>
-                  <a:srgbClr val="C15943"/>
-                </a:solidFill>
-                <a:latin typeface="Poppins"/>
-                <a:ea typeface="Poppins"/>
-                <a:cs typeface="Poppins"/>
-                <a:sym typeface="Poppins"/>
-              </a:rPr>
-              <a:t>purus</a:t>
-            </a:r>
-            <a:r>
-              <a:rPr lang="en-US" sz="2799" dirty="0">
-                <a:solidFill>
-                  <a:srgbClr val="C15943"/>
-                </a:solidFill>
-                <a:latin typeface="Poppins"/>
-                <a:ea typeface="Poppins"/>
-                <a:cs typeface="Poppins"/>
-                <a:sym typeface="Poppins"/>
-              </a:rPr>
-              <a:t>. </a:t>
-            </a:r>
-            <a:r>
-              <a:rPr lang="en-US" sz="2799" dirty="0" err="1">
-                <a:solidFill>
-                  <a:srgbClr val="C15943"/>
-                </a:solidFill>
-                <a:latin typeface="Poppins"/>
-                <a:ea typeface="Poppins"/>
-                <a:cs typeface="Poppins"/>
-                <a:sym typeface="Poppins"/>
-              </a:rPr>
-              <a:t>Phasellus</a:t>
-            </a:r>
-            <a:r>
-              <a:rPr lang="en-US" sz="2799" dirty="0">
-                <a:solidFill>
-                  <a:srgbClr val="C15943"/>
-                </a:solidFill>
-                <a:latin typeface="Poppins"/>
-                <a:ea typeface="Poppins"/>
-                <a:cs typeface="Poppins"/>
-                <a:sym typeface="Poppins"/>
-              </a:rPr>
-              <a:t> a </a:t>
-            </a:r>
-            <a:r>
-              <a:rPr lang="en-US" sz="2799" dirty="0" err="1">
-                <a:solidFill>
-                  <a:srgbClr val="C15943"/>
-                </a:solidFill>
-                <a:latin typeface="Poppins"/>
-                <a:ea typeface="Poppins"/>
-                <a:cs typeface="Poppins"/>
-                <a:sym typeface="Poppins"/>
-              </a:rPr>
-              <a:t>lacus</a:t>
-            </a:r>
-            <a:r>
-              <a:rPr lang="en-US" sz="2799" dirty="0">
-                <a:solidFill>
-                  <a:srgbClr val="C15943"/>
-                </a:solidFill>
-                <a:latin typeface="Poppins"/>
-                <a:ea typeface="Poppins"/>
-                <a:cs typeface="Poppins"/>
-                <a:sym typeface="Poppins"/>
-              </a:rPr>
-              <a:t> sit </a:t>
-            </a:r>
-            <a:r>
-              <a:rPr lang="en-US" sz="2799" dirty="0" err="1">
-                <a:solidFill>
-                  <a:srgbClr val="C15943"/>
-                </a:solidFill>
-                <a:latin typeface="Poppins"/>
-                <a:ea typeface="Poppins"/>
-                <a:cs typeface="Poppins"/>
-                <a:sym typeface="Poppins"/>
-              </a:rPr>
-              <a:t>amet</a:t>
-            </a:r>
-            <a:r>
-              <a:rPr lang="en-US" sz="2799" dirty="0">
-                <a:solidFill>
-                  <a:srgbClr val="C15943"/>
-                </a:solidFill>
-                <a:latin typeface="Poppins"/>
-                <a:ea typeface="Poppins"/>
-                <a:cs typeface="Poppins"/>
-                <a:sym typeface="Poppins"/>
-              </a:rPr>
-              <a:t> </a:t>
-            </a:r>
-            <a:r>
-              <a:rPr lang="en-US" sz="2799" dirty="0" err="1">
-                <a:solidFill>
-                  <a:srgbClr val="C15943"/>
-                </a:solidFill>
-                <a:latin typeface="Poppins"/>
-                <a:ea typeface="Poppins"/>
-                <a:cs typeface="Poppins"/>
-                <a:sym typeface="Poppins"/>
-              </a:rPr>
-              <a:t>urna</a:t>
-            </a:r>
-            <a:r>
-              <a:rPr lang="en-US" sz="2799" dirty="0">
-                <a:solidFill>
-                  <a:srgbClr val="C15943"/>
-                </a:solidFill>
-                <a:latin typeface="Poppins"/>
-                <a:ea typeface="Poppins"/>
-                <a:cs typeface="Poppins"/>
-                <a:sym typeface="Poppins"/>
-              </a:rPr>
-              <a:t> </a:t>
-            </a:r>
-            <a:r>
-              <a:rPr lang="en-US" sz="2799" dirty="0" err="1">
-                <a:solidFill>
-                  <a:srgbClr val="C15943"/>
-                </a:solidFill>
-                <a:latin typeface="Poppins"/>
-                <a:ea typeface="Poppins"/>
-                <a:cs typeface="Poppins"/>
-                <a:sym typeface="Poppins"/>
-              </a:rPr>
-              <a:t>tempor</a:t>
-            </a:r>
-            <a:r>
-              <a:rPr lang="en-US" sz="2799" dirty="0">
-                <a:solidFill>
-                  <a:srgbClr val="C15943"/>
-                </a:solidFill>
-                <a:latin typeface="Poppins"/>
-                <a:ea typeface="Poppins"/>
-                <a:cs typeface="Poppins"/>
-                <a:sym typeface="Poppins"/>
-              </a:rPr>
-              <a:t> </a:t>
-            </a:r>
-            <a:r>
-              <a:rPr lang="en-US" sz="2799" dirty="0" err="1">
-                <a:solidFill>
-                  <a:srgbClr val="C15943"/>
-                </a:solidFill>
-                <a:latin typeface="Poppins"/>
-                <a:ea typeface="Poppins"/>
-                <a:cs typeface="Poppins"/>
-                <a:sym typeface="Poppins"/>
-              </a:rPr>
-              <a:t>sollicitudin</a:t>
-            </a:r>
-            <a:r>
-              <a:rPr lang="en-US" sz="2799" dirty="0">
-                <a:solidFill>
-                  <a:srgbClr val="C15943"/>
-                </a:solidFill>
-                <a:latin typeface="Poppins"/>
-                <a:ea typeface="Poppins"/>
-                <a:cs typeface="Poppins"/>
-                <a:sym typeface="Poppins"/>
-              </a:rPr>
-              <a:t>. Cras </a:t>
-            </a:r>
-            <a:r>
-              <a:rPr lang="en-US" sz="2799" dirty="0" err="1">
-                <a:solidFill>
-                  <a:srgbClr val="C15943"/>
-                </a:solidFill>
-                <a:latin typeface="Poppins"/>
-                <a:ea typeface="Poppins"/>
-                <a:cs typeface="Poppins"/>
-                <a:sym typeface="Poppins"/>
-              </a:rPr>
-              <a:t>pretium</a:t>
-            </a:r>
-            <a:r>
-              <a:rPr lang="en-US" sz="2799" dirty="0">
-                <a:solidFill>
-                  <a:srgbClr val="C15943"/>
-                </a:solidFill>
-                <a:latin typeface="Poppins"/>
-                <a:ea typeface="Poppins"/>
-                <a:cs typeface="Poppins"/>
-                <a:sym typeface="Poppins"/>
-              </a:rPr>
-              <a:t> </a:t>
-            </a:r>
-            <a:r>
-              <a:rPr lang="en-US" sz="2799" dirty="0" err="1">
-                <a:solidFill>
-                  <a:srgbClr val="C15943"/>
-                </a:solidFill>
-                <a:latin typeface="Poppins"/>
-                <a:ea typeface="Poppins"/>
-                <a:cs typeface="Poppins"/>
-                <a:sym typeface="Poppins"/>
-              </a:rPr>
-              <a:t>tempor</a:t>
-            </a:r>
-            <a:r>
-              <a:rPr lang="en-US" sz="2799" dirty="0">
-                <a:solidFill>
-                  <a:srgbClr val="C15943"/>
-                </a:solidFill>
-                <a:latin typeface="Poppins"/>
-                <a:ea typeface="Poppins"/>
-                <a:cs typeface="Poppins"/>
-                <a:sym typeface="Poppins"/>
-              </a:rPr>
-              <a:t> </a:t>
-            </a:r>
-            <a:r>
-              <a:rPr lang="en-US" sz="2799" dirty="0" err="1">
-                <a:solidFill>
-                  <a:srgbClr val="C15943"/>
-                </a:solidFill>
-                <a:latin typeface="Poppins"/>
-                <a:ea typeface="Poppins"/>
-                <a:cs typeface="Poppins"/>
-                <a:sym typeface="Poppins"/>
-              </a:rPr>
-              <a:t>elit</a:t>
-            </a:r>
-            <a:r>
-              <a:rPr lang="en-US" sz="2799" dirty="0">
-                <a:solidFill>
-                  <a:srgbClr val="C15943"/>
-                </a:solidFill>
-                <a:latin typeface="Poppins"/>
-                <a:ea typeface="Poppins"/>
-                <a:cs typeface="Poppins"/>
-                <a:sym typeface="Poppins"/>
-              </a:rPr>
-              <a:t> </a:t>
-            </a:r>
-            <a:r>
-              <a:rPr lang="en-US" sz="2799" dirty="0" err="1">
-                <a:solidFill>
-                  <a:srgbClr val="C15943"/>
-                </a:solidFill>
-                <a:latin typeface="Poppins"/>
-                <a:ea typeface="Poppins"/>
-                <a:cs typeface="Poppins"/>
-                <a:sym typeface="Poppins"/>
-              </a:rPr>
-              <a:t>blandit</a:t>
-            </a:r>
-            <a:r>
-              <a:rPr lang="en-US" sz="2799" dirty="0">
-                <a:solidFill>
-                  <a:srgbClr val="C15943"/>
-                </a:solidFill>
-                <a:latin typeface="Poppins"/>
-                <a:ea typeface="Poppins"/>
-                <a:cs typeface="Poppins"/>
-                <a:sym typeface="Poppins"/>
-              </a:rPr>
-              <a:t> </a:t>
-            </a:r>
-            <a:r>
-              <a:rPr lang="en-US" sz="2799" dirty="0" err="1">
-                <a:solidFill>
-                  <a:srgbClr val="C15943"/>
-                </a:solidFill>
-                <a:latin typeface="Poppins"/>
-                <a:ea typeface="Poppins"/>
-                <a:cs typeface="Poppins"/>
-                <a:sym typeface="Poppins"/>
-              </a:rPr>
-              <a:t>egestas</a:t>
-            </a:r>
-            <a:r>
-              <a:rPr lang="en-US" sz="2799" dirty="0">
-                <a:solidFill>
-                  <a:srgbClr val="C15943"/>
-                </a:solidFill>
-                <a:latin typeface="Poppins"/>
-                <a:ea typeface="Poppins"/>
-                <a:cs typeface="Poppins"/>
-                <a:sym typeface="Poppins"/>
-              </a:rPr>
-              <a:t>. Donec sed </a:t>
-            </a:r>
-            <a:r>
-              <a:rPr lang="en-US" sz="2799" dirty="0" err="1">
-                <a:solidFill>
-                  <a:srgbClr val="C15943"/>
-                </a:solidFill>
-                <a:latin typeface="Poppins"/>
-                <a:ea typeface="Poppins"/>
-                <a:cs typeface="Poppins"/>
-                <a:sym typeface="Poppins"/>
-              </a:rPr>
-              <a:t>dignissim</a:t>
-            </a:r>
-            <a:r>
-              <a:rPr lang="en-US" sz="2799" dirty="0">
-                <a:solidFill>
-                  <a:srgbClr val="C15943"/>
-                </a:solidFill>
-                <a:latin typeface="Poppins"/>
-                <a:ea typeface="Poppins"/>
-                <a:cs typeface="Poppins"/>
-                <a:sym typeface="Poppins"/>
-              </a:rPr>
-              <a:t> </a:t>
-            </a:r>
-            <a:r>
-              <a:rPr lang="en-US" sz="2799" dirty="0" err="1">
-                <a:solidFill>
-                  <a:srgbClr val="C15943"/>
-                </a:solidFill>
-                <a:latin typeface="Poppins"/>
-                <a:ea typeface="Poppins"/>
-                <a:cs typeface="Poppins"/>
-                <a:sym typeface="Poppins"/>
-              </a:rPr>
-              <a:t>augue</a:t>
-            </a:r>
-            <a:r>
-              <a:rPr lang="en-US" sz="2799" dirty="0">
-                <a:solidFill>
-                  <a:srgbClr val="C15943"/>
-                </a:solidFill>
-                <a:latin typeface="Poppins"/>
-                <a:ea typeface="Poppins"/>
-                <a:cs typeface="Poppins"/>
-                <a:sym typeface="Poppins"/>
-              </a:rPr>
-              <a:t>. </a:t>
-            </a:r>
-            <a:r>
-              <a:rPr lang="en-US" sz="2799" dirty="0" err="1">
-                <a:solidFill>
-                  <a:srgbClr val="C15943"/>
-                </a:solidFill>
-                <a:latin typeface="Poppins"/>
-                <a:ea typeface="Poppins"/>
-                <a:cs typeface="Poppins"/>
-                <a:sym typeface="Poppins"/>
-              </a:rPr>
-              <a:t>Suspendisse</a:t>
-            </a:r>
-            <a:r>
-              <a:rPr lang="en-US" sz="2799" dirty="0">
-                <a:solidFill>
-                  <a:srgbClr val="C15943"/>
-                </a:solidFill>
-                <a:latin typeface="Poppins"/>
-                <a:ea typeface="Poppins"/>
-                <a:cs typeface="Poppins"/>
-                <a:sym typeface="Poppins"/>
-              </a:rPr>
-              <a:t> ac </a:t>
-            </a:r>
-            <a:r>
-              <a:rPr lang="en-US" sz="2799" dirty="0" err="1">
-                <a:solidFill>
-                  <a:srgbClr val="C15943"/>
-                </a:solidFill>
-                <a:latin typeface="Poppins"/>
-                <a:ea typeface="Poppins"/>
-                <a:cs typeface="Poppins"/>
-                <a:sym typeface="Poppins"/>
-              </a:rPr>
-              <a:t>vulputate</a:t>
-            </a:r>
-            <a:r>
-              <a:rPr lang="en-US" sz="2799" dirty="0">
-                <a:solidFill>
-                  <a:srgbClr val="C15943"/>
-                </a:solidFill>
-                <a:latin typeface="Poppins"/>
-                <a:ea typeface="Poppins"/>
-                <a:cs typeface="Poppins"/>
-                <a:sym typeface="Poppins"/>
-              </a:rPr>
-              <a:t> </a:t>
-            </a:r>
-            <a:r>
-              <a:rPr lang="en-US" sz="2799" dirty="0" err="1">
-                <a:solidFill>
-                  <a:srgbClr val="C15943"/>
-                </a:solidFill>
-                <a:latin typeface="Poppins"/>
-                <a:ea typeface="Poppins"/>
-                <a:cs typeface="Poppins"/>
-                <a:sym typeface="Poppins"/>
-              </a:rPr>
-              <a:t>leo</a:t>
-            </a:r>
-            <a:r>
-              <a:rPr lang="en-US" sz="2799" dirty="0">
-                <a:solidFill>
-                  <a:srgbClr val="C15943"/>
-                </a:solidFill>
-                <a:latin typeface="Poppins"/>
-                <a:ea typeface="Poppins"/>
-                <a:cs typeface="Poppins"/>
-                <a:sym typeface="Poppins"/>
-              </a:rPr>
-              <a:t>. Cras </a:t>
-            </a:r>
-            <a:r>
-              <a:rPr lang="en-US" sz="2799" dirty="0" err="1">
-                <a:solidFill>
-                  <a:srgbClr val="C15943"/>
-                </a:solidFill>
-                <a:latin typeface="Poppins"/>
-                <a:ea typeface="Poppins"/>
-                <a:cs typeface="Poppins"/>
-                <a:sym typeface="Poppins"/>
-              </a:rPr>
-              <a:t>aliquet</a:t>
-            </a:r>
-            <a:r>
-              <a:rPr lang="en-US" sz="2799" dirty="0">
-                <a:solidFill>
-                  <a:srgbClr val="C15943"/>
-                </a:solidFill>
-                <a:latin typeface="Poppins"/>
-                <a:ea typeface="Poppins"/>
-                <a:cs typeface="Poppins"/>
-                <a:sym typeface="Poppins"/>
-              </a:rPr>
-              <a:t> nunc ac </a:t>
-            </a:r>
-            <a:r>
-              <a:rPr lang="en-US" sz="2799" dirty="0" err="1">
-                <a:solidFill>
-                  <a:srgbClr val="C15943"/>
-                </a:solidFill>
-                <a:latin typeface="Poppins"/>
-                <a:ea typeface="Poppins"/>
-                <a:cs typeface="Poppins"/>
-                <a:sym typeface="Poppins"/>
-              </a:rPr>
-              <a:t>velit</a:t>
-            </a:r>
-            <a:r>
-              <a:rPr lang="en-US" sz="2799" dirty="0">
-                <a:solidFill>
-                  <a:srgbClr val="C15943"/>
-                </a:solidFill>
-                <a:latin typeface="Poppins"/>
-                <a:ea typeface="Poppins"/>
-                <a:cs typeface="Poppins"/>
-                <a:sym typeface="Poppins"/>
-              </a:rPr>
-              <a:t> cursus </a:t>
-            </a:r>
-            <a:r>
-              <a:rPr lang="en-US" sz="2799" dirty="0" err="1">
-                <a:solidFill>
-                  <a:srgbClr val="C15943"/>
-                </a:solidFill>
-                <a:latin typeface="Poppins"/>
-                <a:ea typeface="Poppins"/>
-                <a:cs typeface="Poppins"/>
-                <a:sym typeface="Poppins"/>
-              </a:rPr>
-              <a:t>viverra</a:t>
-            </a:r>
-            <a:r>
-              <a:rPr lang="en-US" sz="2799" dirty="0">
-                <a:solidFill>
-                  <a:srgbClr val="C15943"/>
-                </a:solidFill>
-                <a:latin typeface="Poppins"/>
-                <a:ea typeface="Poppins"/>
-                <a:cs typeface="Poppins"/>
-                <a:sym typeface="Poppins"/>
-              </a:rPr>
-              <a:t>.</a:t>
+              <a:rPr lang="en-US" sz="2799">
+                <a:solidFill>
+                  <a:srgbClr val="C15943"/>
+                </a:solidFill>
+                <a:latin typeface="Poppins"/>
+                <a:ea typeface="Poppins"/>
+                <a:cs typeface="Poppins"/>
+                <a:sym typeface="Poppins"/>
+              </a:rPr>
+              <a:t>Lorem ipsum dolor sit amet, consectetur adipiscing elit. Quisque non elit mauris. Cras euismod, metus ac finibus finibus, felis dui suscipit purus, a maximus leo ligula at dolor. Morbi et malesuada purus. Phasellus a lacus sit amet urna tempor sollicitudin. Cras pretium tempor elit blandit egestas. Donec sed dignissim augue. Suspendisse ac vulputate leo. Cras aliquet nunc ac velit cursus viverra.</a:t>
             </a:r>
           </a:p>
         </p:txBody>
@@ -6322,177 +6696,6 @@
                 <a:sym typeface="Montaser Arabic Bold"/>
               </a:rPr>
               <a:t>REAL EXAMPLES</a:t>
-            </a:r>
-          </a:p>
-        </p:txBody>
-      </p:sp>
-    </p:spTree>
-  </p:cSld>
-  <p:clrMapOvr>
-    <a:masterClrMapping/>
-  </p:clrMapOvr>
-</p:sld>
-</file>
-
-<file path=ppt/slides/slide6.xml><?xml version="1.0" encoding="utf-8"?>
-<p:sld xmlns:a="http://schemas.openxmlformats.org/drawingml/2006/main" xmlns:r="http://schemas.openxmlformats.org/officeDocument/2006/relationships" xmlns:p="http://schemas.openxmlformats.org/presentationml/2006/main">
-  <p:cSld>
-    <p:bg>
-      <p:bgPr>
-        <a:blipFill dpi="0" rotWithShape="1">
-          <a:blip r:embed="rId2">
-            <a:lum/>
-          </a:blip>
-          <a:srcRect/>
-          <a:stretch>
-            <a:fillRect/>
-          </a:stretch>
-        </a:blipFill>
-        <a:effectLst/>
-      </p:bgPr>
-    </p:bg>
-    <p:spTree>
-      <p:nvGrpSpPr>
-        <p:cNvPr id="1" name=""/>
-        <p:cNvGrpSpPr/>
-        <p:nvPr/>
-      </p:nvGrpSpPr>
-      <p:grpSpPr>
-        <a:xfrm>
-          <a:off x="0" y="0"/>
-          <a:ext cx="0" cy="0"/>
-          <a:chOff x="0" y="0"/>
-          <a:chExt cx="0" cy="0"/>
-        </a:xfrm>
-      </p:grpSpPr>
-      <p:sp>
-        <p:nvSpPr>
-          <p:cNvPr id="7" name="Freeform 7"/>
-          <p:cNvSpPr/>
-          <p:nvPr/>
-        </p:nvSpPr>
-        <p:spPr>
-          <a:xfrm>
-            <a:off x="9144000" y="3562749"/>
-            <a:ext cx="8115300" cy="5695551"/>
-          </a:xfrm>
-          <a:custGeom>
-            <a:avLst/>
-            <a:gdLst/>
-            <a:ahLst/>
-            <a:cxnLst/>
-            <a:rect l="l" t="t" r="r" b="b"/>
-            <a:pathLst>
-              <a:path w="2137363" h="1500063">
-                <a:moveTo>
-                  <a:pt x="0" y="0"/>
-                </a:moveTo>
-                <a:lnTo>
-                  <a:pt x="2137363" y="0"/>
-                </a:lnTo>
-                <a:lnTo>
-                  <a:pt x="2137363" y="1500063"/>
-                </a:lnTo>
-                <a:lnTo>
-                  <a:pt x="0" y="1500063"/>
-                </a:lnTo>
-                <a:close/>
-              </a:path>
-            </a:pathLst>
-          </a:custGeom>
-          <a:solidFill>
-            <a:srgbClr val="FFE9E4"/>
-          </a:solidFill>
-          <a:ln w="38100" cap="sq">
-            <a:solidFill>
-              <a:srgbClr val="C15943"/>
-            </a:solidFill>
-            <a:prstDash val="solid"/>
-            <a:miter/>
-          </a:ln>
-        </p:spPr>
-        <p:txBody>
-          <a:bodyPr/>
-          <a:lstStyle/>
-          <a:p>
-            <a:endParaRPr lang="ru-RU"/>
-          </a:p>
-        </p:txBody>
-      </p:sp>
-      <p:sp>
-        <p:nvSpPr>
-          <p:cNvPr id="12" name="TextBox 12"/>
-          <p:cNvSpPr txBox="1"/>
-          <p:nvPr/>
-        </p:nvSpPr>
-        <p:spPr>
-          <a:xfrm>
-            <a:off x="1588796" y="3562749"/>
-            <a:ext cx="7116137" cy="2709672"/>
-          </a:xfrm>
-          <a:prstGeom prst="rect">
-            <a:avLst/>
-          </a:prstGeom>
-        </p:spPr>
-        <p:txBody>
-          <a:bodyPr lIns="0" tIns="0" rIns="0" bIns="0" rtlCol="0" anchor="t">
-            <a:spAutoFit/>
-          </a:bodyPr>
-          <a:lstStyle/>
-          <a:p>
-            <a:pPr algn="l">
-              <a:lnSpc>
-                <a:spcPts val="3023"/>
-              </a:lnSpc>
-            </a:pPr>
-            <a:r>
-              <a:rPr lang="en-US" sz="2799">
-                <a:solidFill>
-                  <a:srgbClr val="C15943"/>
-                </a:solidFill>
-                <a:latin typeface="Poppins"/>
-                <a:ea typeface="Poppins"/>
-                <a:cs typeface="Poppins"/>
-                <a:sym typeface="Poppins"/>
-              </a:rPr>
-              <a:t>Lorem ipsum dolor sit amet, consectetur adipiscing elit. Quisque non elit mauris. Cras euismod, metus ac finibus finibus, felis dui suscipit purus, a maximus leo ligula at dolor. Morbi et malesuada purus. Phasellus a lacus sit amet urna tempor sollicitudin.</a:t>
-            </a:r>
-          </a:p>
-        </p:txBody>
-      </p:sp>
-      <p:sp>
-        <p:nvSpPr>
-          <p:cNvPr id="13" name="TextBox 13"/>
-          <p:cNvSpPr txBox="1"/>
-          <p:nvPr/>
-        </p:nvSpPr>
-        <p:spPr>
-          <a:xfrm>
-            <a:off x="1588796" y="1485900"/>
-            <a:ext cx="10061192" cy="615553"/>
-          </a:xfrm>
-          <a:prstGeom prst="rect">
-            <a:avLst/>
-          </a:prstGeom>
-        </p:spPr>
-        <p:txBody>
-          <a:bodyPr lIns="0" tIns="0" rIns="0" bIns="0" rtlCol="0" anchor="t">
-            <a:spAutoFit/>
-          </a:bodyPr>
-          <a:lstStyle/>
-          <a:p>
-            <a:pPr algn="l"/>
-            <a:r>
-              <a:rPr lang="en-US" sz="4000" b="1" dirty="0">
-                <a:solidFill>
-                  <a:srgbClr val="C15943"/>
-                </a:solidFill>
-                <a:latin typeface="Montaser Arabic Bold"/>
-                <a:ea typeface="Montaser Arabic Bold"/>
-                <a:cs typeface="Montaser Arabic Bold"/>
-                <a:sym typeface="Montaser Arabic Bold"/>
-              </a:rPr>
-              <a:t>DATA HIGHLIGHTS</a:t>
             </a:r>
           </a:p>
         </p:txBody>

</xml_diff>